<commit_message>
Increase body font size in humanoid robots presentation
Co-Authored-By: Claude Sonnet 5.5 <noreply@anthropic.com>
Claude-Session: https://claude.ai/code/session_01QoBEPxbicZNbtosTbAi2im
</commit_message>
<xml_diff>
--- a/Humanoide_Roboter.pptx
+++ b/Humanoide_Roboter.pptx
@@ -137,7 +137,7 @@
   <p:extLst>
     <p:ext uri="{521415D9-36F7-43E2-AB2F-B90AF26B5E84}">
       <p14:sectionLst xmlns:p14="http://schemas.microsoft.com/office/powerpoint/2010/main">
-        <p14:section name="Teil 1: Geschichte der humanoiden Roboter" id="{67779345-984e-994c-d648-edc51870e610}">
+        <p14:section name="Teil 1: Geschichte der humanoiden Roboter" id="{7f09f317-b7e5-9ef6-baa7-41611607c7a4}">
           <p14:sldIdLst>
             <p14:sldId id="257"/>
             <p14:sldId id="258"/>
@@ -146,7 +146,7 @@
             <p14:sldId id="261"/>
           </p14:sldIdLst>
         </p14:section>
-        <p14:section name="Teil 2: Sport, Athletik und Wettkämpfe" id="{5e3eaa75-fa33-f6d6-27ff-bebd42f54ee4}">
+        <p14:section name="Teil 2: Sport, Athletik und Wettkämpfe" id="{ca0c7ce2-2196-97d0-66b1-6d7ea5ab9642}">
           <p14:sldIdLst>
             <p14:sldId id="262"/>
             <p14:sldId id="263"/>
@@ -156,7 +156,7 @@
             <p14:sldId id="267"/>
           </p14:sldIdLst>
         </p14:section>
-        <p14:section name="Teil 3: Industrie &amp; Fabriken" id="{dd40d6ab-c6f4-9355-f26c-82eb76e34d04}">
+        <p14:section name="Teil 3: Industrie &amp; Fabriken" id="{5a8085a2-6acc-0edf-57f9-d8c98b88d0d5}">
           <p14:sldIdLst>
             <p14:sldId id="268"/>
             <p14:sldId id="269"/>
@@ -166,7 +166,7 @@
             <p14:sldId id="273"/>
           </p14:sldIdLst>
         </p14:section>
-        <p14:section name="Teil 4: Künstliche Intelligenz &amp; Schlüsseltechnologien" id="{c4c20439-8cd1-8aa9-9a76-21d03b6e8259}">
+        <p14:section name="Teil 4: Künstliche Intelligenz &amp; Schlüsseltechnologien" id="{7fe6e87f-c448-dfc7-f88a-93ab1669c24b}">
           <p14:sldIdLst>
             <p14:sldId id="274"/>
             <p14:sldId id="275"/>
@@ -176,7 +176,7 @@
             <p14:sldId id="279"/>
           </p14:sldIdLst>
         </p14:section>
-        <p14:section name="Teil 5: Haushaltsroboter &amp; Zukunftsprognosen" id="{1a2af165-5e83-2248-ab7e-19673f946572}">
+        <p14:section name="Teil 5: Haushaltsroboter &amp; Zukunftsprognosen" id="{541b6acb-09a5-1a1c-55a0-7c4c10cab717}">
           <p14:sldIdLst>
             <p14:sldId id="280"/>
             <p14:sldId id="281"/>
@@ -3336,7 +3336,7 @@
         <p:spPr>
           <a:xfrm>
             <a:off x="0" y="0"/>
-            <a:ext cx="4892040" cy="5143500"/>
+            <a:ext cx="5257800" cy="5143500"/>
           </a:xfrm>
           <a:prstGeom prst="rect">
             <a:avLst/>
@@ -3920,8 +3920,8 @@
         </p:nvSpPr>
         <p:spPr>
           <a:xfrm>
-            <a:off x="457200" y="640080"/>
-            <a:ext cx="4160520" cy="1051560"/>
+            <a:off x="457200" y="594360"/>
+            <a:ext cx="4572000" cy="1143000"/>
           </a:xfrm>
           <a:prstGeom prst="rect">
             <a:avLst/>
@@ -3939,7 +3939,7 @@
               <a:buNone/>
             </a:pPr>
             <a:r>
-              <a:rPr lang="en-US" sz="2400" b="1" dirty="0">
+              <a:rPr lang="en-US" sz="2600" b="1" dirty="0">
                 <a:solidFill>
                   <a:schemeClr val="tx2"/>
                 </a:solidFill>
@@ -3949,7 +3949,7 @@
               </a:rPr>
               <a:t>Laufdynamik: Sprints und Halbmarathons</a:t>
             </a:r>
-            <a:endParaRPr lang="en-US" sz="2400" dirty="0"/>
+            <a:endParaRPr lang="en-US" sz="2600" dirty="0"/>
           </a:p>
         </p:txBody>
       </p:sp>
@@ -3961,36 +3961,31 @@
         </p:nvSpPr>
         <p:spPr>
           <a:xfrm>
-            <a:off x="457200" y="1783080"/>
-            <a:ext cx="4160520" cy="2834640"/>
-          </a:xfrm>
-          <a:prstGeom prst="rect">
-            <a:avLst/>
-          </a:prstGeom>
-          <a:noFill/>
-          <a:ln/>
-        </p:spPr>
-        <p:txBody>
-          <a:bodyPr wrap="square" lIns="0" tIns="0" rIns="0" bIns="0" rtlCol="0" anchor="t">
-            <a:normAutofit/>
-          </a:bodyPr>
-          <a:lstStyle/>
-          <a:p>
-            <a:pPr indent="0" marL="0">
-              <a:spcAft>
-                <a:spcPts val="600"/>
-              </a:spcAft>
-              <a:buNone/>
-            </a:pPr>
-            <a:r>
-              <a:rPr lang="en-US" sz="1500" dirty="0">
+            <a:off x="457200" y="1828800"/>
+            <a:ext cx="4572000" cy="2834640"/>
+          </a:xfrm>
+          <a:prstGeom prst="rect">
+            <a:avLst/>
+          </a:prstGeom>
+          <a:noFill/>
+          <a:ln/>
+        </p:spPr>
+        <p:txBody>
+          <a:bodyPr wrap="square" lIns="0" tIns="0" rIns="0" bIns="0" rtlCol="0" anchor="t"/>
+          <a:lstStyle/>
+          <a:p>
+            <a:pPr indent="0" marL="0">
+              <a:buNone/>
+            </a:pPr>
+            <a:r>
+              <a:rPr lang="en-US" sz="2200" dirty="0">
                 <a:solidFill>
                   <a:schemeClr val="tx1"/>
                 </a:solidFill>
               </a:rPr>
               <a:t>Moderne Humanoide erreichen beachtliche Sprintgeschwindigkeiten und meistern in China sogar Laufstrecken von über 21 Kilometern. Elastische Sehnen und schnelle Motoren dämpfen dabei die starken Stöße auf dem harten Asphalt ab.</a:t>
             </a:r>
-            <a:endParaRPr lang="en-US" sz="1500" dirty="0"/>
+            <a:endParaRPr lang="en-US" sz="2200" dirty="0"/>
           </a:p>
         </p:txBody>
       </p:sp>
@@ -4038,8 +4033,8 @@
         </p:nvSpPr>
         <p:spPr>
           <a:xfrm>
-            <a:off x="5257800" y="822960"/>
-            <a:ext cx="3429000" cy="2651760"/>
+            <a:off x="5486400" y="822960"/>
+            <a:ext cx="3200400" cy="2651760"/>
           </a:xfrm>
           <a:prstGeom prst="roundRect">
             <a:avLst>
@@ -4065,8 +4060,8 @@
         </p:nvSpPr>
         <p:spPr>
           <a:xfrm>
-            <a:off x="5257800" y="960120"/>
-            <a:ext cx="3429000" cy="822960"/>
+            <a:off x="5486400" y="960120"/>
+            <a:ext cx="3200400" cy="822960"/>
           </a:xfrm>
           <a:prstGeom prst="rect">
             <a:avLst/>
@@ -4104,8 +4099,8 @@
         </p:nvSpPr>
         <p:spPr>
           <a:xfrm>
-            <a:off x="5486400" y="1874520"/>
-            <a:ext cx="2971800" cy="1463040"/>
+            <a:off x="5715000" y="1874520"/>
+            <a:ext cx="2743200" cy="1463040"/>
           </a:xfrm>
           <a:prstGeom prst="rect">
             <a:avLst/>
@@ -4140,8 +4135,8 @@
         </p:nvSpPr>
         <p:spPr>
           <a:xfrm>
-            <a:off x="5257800" y="3566160"/>
-            <a:ext cx="3429000" cy="228600"/>
+            <a:off x="5486400" y="3566160"/>
+            <a:ext cx="3200400" cy="228600"/>
           </a:xfrm>
           <a:prstGeom prst="rect">
             <a:avLst/>
@@ -4237,8 +4232,8 @@
         </p:nvSpPr>
         <p:spPr>
           <a:xfrm>
-            <a:off x="457200" y="640080"/>
-            <a:ext cx="4160520" cy="1051560"/>
+            <a:off x="457200" y="594360"/>
+            <a:ext cx="4572000" cy="1143000"/>
           </a:xfrm>
           <a:prstGeom prst="rect">
             <a:avLst/>
@@ -4256,7 +4251,7 @@
               <a:buNone/>
             </a:pPr>
             <a:r>
-              <a:rPr lang="en-US" sz="2400" b="1" dirty="0">
+              <a:rPr lang="en-US" sz="2600" b="1" dirty="0">
                 <a:solidFill>
                   <a:schemeClr val="tx2"/>
                 </a:solidFill>
@@ -4266,48 +4261,43 @@
               </a:rPr>
               <a:t>Parkour und Rückwärtssaltos</a:t>
             </a:r>
+            <a:endParaRPr lang="en-US" sz="2600" dirty="0"/>
+          </a:p>
+        </p:txBody>
+      </p:sp>
+      <p:sp>
+        <p:nvSpPr>
+          <p:cNvPr id="4" name="Text"/>
+          <p:cNvSpPr txBox="1"/>
+          <p:nvPr/>
+        </p:nvSpPr>
+        <p:spPr>
+          <a:xfrm>
+            <a:off x="457200" y="1828800"/>
+            <a:ext cx="4572000" cy="2834640"/>
+          </a:xfrm>
+          <a:prstGeom prst="rect">
+            <a:avLst/>
+          </a:prstGeom>
+          <a:noFill/>
+          <a:ln/>
+        </p:spPr>
+        <p:txBody>
+          <a:bodyPr wrap="square" lIns="0" tIns="0" rIns="0" bIns="0" rtlCol="0" anchor="t"/>
+          <a:lstStyle/>
+          <a:p>
+            <a:pPr indent="0" marL="0">
+              <a:buNone/>
+            </a:pPr>
+            <a:r>
+              <a:rPr lang="en-US" sz="2400" dirty="0">
+                <a:solidFill>
+                  <a:schemeClr val="tx1"/>
+                </a:solidFill>
+              </a:rPr>
+              <a:t>Hochentwickelte Algorithmen erlauben es Robotern, über Holzkisten und schmale Balken zu springen. Nach einem Salto in der Luft berechnet der Bordcomputer die Landung in Echtzeit.</a:t>
+            </a:r>
             <a:endParaRPr lang="en-US" sz="2400" dirty="0"/>
-          </a:p>
-        </p:txBody>
-      </p:sp>
-      <p:sp>
-        <p:nvSpPr>
-          <p:cNvPr id="4" name="Text"/>
-          <p:cNvSpPr txBox="1"/>
-          <p:nvPr/>
-        </p:nvSpPr>
-        <p:spPr>
-          <a:xfrm>
-            <a:off x="457200" y="1783080"/>
-            <a:ext cx="4160520" cy="2834640"/>
-          </a:xfrm>
-          <a:prstGeom prst="rect">
-            <a:avLst/>
-          </a:prstGeom>
-          <a:noFill/>
-          <a:ln/>
-        </p:spPr>
-        <p:txBody>
-          <a:bodyPr wrap="square" lIns="0" tIns="0" rIns="0" bIns="0" rtlCol="0" anchor="t">
-            <a:normAutofit/>
-          </a:bodyPr>
-          <a:lstStyle/>
-          <a:p>
-            <a:pPr indent="0" marL="0">
-              <a:spcAft>
-                <a:spcPts val="600"/>
-              </a:spcAft>
-              <a:buNone/>
-            </a:pPr>
-            <a:r>
-              <a:rPr lang="en-US" sz="1500" dirty="0">
-                <a:solidFill>
-                  <a:schemeClr val="tx1"/>
-                </a:solidFill>
-              </a:rPr>
-              <a:t>Hochentwickelte Algorithmen erlauben es Robotern, über Holzkisten und schmale Balken zu springen. Nach einem Salto in der Luft berechnet der Bordcomputer die Landung in Echtzeit.</a:t>
-            </a:r>
-            <a:endParaRPr lang="en-US" sz="1500" dirty="0"/>
           </a:p>
         </p:txBody>
       </p:sp>
@@ -4365,8 +4355,8 @@
         </p:blipFill>
         <p:spPr>
           <a:xfrm>
-            <a:off x="5257800" y="822960"/>
-            <a:ext cx="3429000" cy="1928813"/>
+            <a:off x="5486400" y="822960"/>
+            <a:ext cx="3200400" cy="1800225"/>
           </a:xfrm>
           <a:prstGeom prst="rect">
             <a:avLst/>
@@ -4383,7 +4373,7 @@
         </p:nvSpPr>
         <p:spPr>
           <a:xfrm>
-            <a:off x="6652260" y="1467326"/>
+            <a:off x="6766560" y="1403032"/>
             <a:ext cx="640080" cy="640080"/>
           </a:xfrm>
           <a:prstGeom prst="ellipse">
@@ -4412,7 +4402,7 @@
         </p:nvSpPr>
         <p:spPr>
           <a:xfrm rot="5400000">
-            <a:off x="6880860" y="1641062"/>
+            <a:off x="6995160" y="1576769"/>
             <a:ext cx="256032" cy="292608"/>
           </a:xfrm>
           <a:prstGeom prst="triangle">
@@ -4437,8 +4427,8 @@
         </p:nvSpPr>
         <p:spPr>
           <a:xfrm>
-            <a:off x="5257800" y="2843213"/>
-            <a:ext cx="3429000" cy="548640"/>
+            <a:off x="5486400" y="2714625"/>
+            <a:ext cx="3200400" cy="548640"/>
           </a:xfrm>
           <a:prstGeom prst="rect">
             <a:avLst/>
@@ -4473,8 +4463,8 @@
         </p:nvSpPr>
         <p:spPr>
           <a:xfrm>
-            <a:off x="5257800" y="3566160"/>
-            <a:ext cx="3429000" cy="502920"/>
+            <a:off x="5486400" y="3566160"/>
+            <a:ext cx="3200400" cy="502920"/>
           </a:xfrm>
           <a:prstGeom prst="rect">
             <a:avLst/>
@@ -4591,8 +4581,8 @@
         </p:nvSpPr>
         <p:spPr>
           <a:xfrm>
-            <a:off x="457200" y="640080"/>
-            <a:ext cx="4160520" cy="1051560"/>
+            <a:off x="457200" y="594360"/>
+            <a:ext cx="4572000" cy="1143000"/>
           </a:xfrm>
           <a:prstGeom prst="rect">
             <a:avLst/>
@@ -4610,7 +4600,7 @@
               <a:buNone/>
             </a:pPr>
             <a:r>
-              <a:rPr lang="en-US" sz="2400" b="1" dirty="0">
+              <a:rPr lang="en-US" sz="2600" b="1" dirty="0">
                 <a:solidFill>
                   <a:schemeClr val="tx2"/>
                 </a:solidFill>
@@ -4620,48 +4610,43 @@
               </a:rPr>
               <a:t>Synchrontanz und Rhythmusgefühl</a:t>
             </a:r>
+            <a:endParaRPr lang="en-US" sz="2600" dirty="0"/>
+          </a:p>
+        </p:txBody>
+      </p:sp>
+      <p:sp>
+        <p:nvSpPr>
+          <p:cNvPr id="4" name="Text"/>
+          <p:cNvSpPr txBox="1"/>
+          <p:nvPr/>
+        </p:nvSpPr>
+        <p:spPr>
+          <a:xfrm>
+            <a:off x="457200" y="1828800"/>
+            <a:ext cx="4572000" cy="2834640"/>
+          </a:xfrm>
+          <a:prstGeom prst="rect">
+            <a:avLst/>
+          </a:prstGeom>
+          <a:noFill/>
+          <a:ln/>
+        </p:spPr>
+        <p:txBody>
+          <a:bodyPr wrap="square" lIns="0" tIns="0" rIns="0" bIns="0" rtlCol="0" anchor="t"/>
+          <a:lstStyle/>
+          <a:p>
+            <a:pPr indent="0" marL="0">
+              <a:buNone/>
+            </a:pPr>
+            <a:r>
+              <a:rPr lang="en-US" sz="2400" dirty="0">
+                <a:solidFill>
+                  <a:schemeClr val="tx1"/>
+                </a:solidFill>
+              </a:rPr>
+              <a:t>Dank präziser Bewegungssteuerung können mehrere humanoide Roboter synchron zur Musik tanzen. Diese Choreografien beweisen die erstaunliche Geschmeidigkeit und Balance moderner Maschinen.</a:t>
+            </a:r>
             <a:endParaRPr lang="en-US" sz="2400" dirty="0"/>
-          </a:p>
-        </p:txBody>
-      </p:sp>
-      <p:sp>
-        <p:nvSpPr>
-          <p:cNvPr id="4" name="Text"/>
-          <p:cNvSpPr txBox="1"/>
-          <p:nvPr/>
-        </p:nvSpPr>
-        <p:spPr>
-          <a:xfrm>
-            <a:off x="457200" y="1783080"/>
-            <a:ext cx="4160520" cy="2834640"/>
-          </a:xfrm>
-          <a:prstGeom prst="rect">
-            <a:avLst/>
-          </a:prstGeom>
-          <a:noFill/>
-          <a:ln/>
-        </p:spPr>
-        <p:txBody>
-          <a:bodyPr wrap="square" lIns="0" tIns="0" rIns="0" bIns="0" rtlCol="0" anchor="t">
-            <a:normAutofit/>
-          </a:bodyPr>
-          <a:lstStyle/>
-          <a:p>
-            <a:pPr indent="0" marL="0">
-              <a:spcAft>
-                <a:spcPts val="600"/>
-              </a:spcAft>
-              <a:buNone/>
-            </a:pPr>
-            <a:r>
-              <a:rPr lang="en-US" sz="1500" dirty="0">
-                <a:solidFill>
-                  <a:schemeClr val="tx1"/>
-                </a:solidFill>
-              </a:rPr>
-              <a:t>Dank präziser Bewegungssteuerung können mehrere humanoide Roboter synchron zur Musik tanzen. Diese Choreografien beweisen die erstaunliche Geschmeidigkeit und Balance moderner Maschinen.</a:t>
-            </a:r>
-            <a:endParaRPr lang="en-US" sz="1500" dirty="0"/>
           </a:p>
         </p:txBody>
       </p:sp>
@@ -4719,8 +4704,8 @@
         </p:blipFill>
         <p:spPr>
           <a:xfrm>
-            <a:off x="5257800" y="822960"/>
-            <a:ext cx="3429000" cy="1928813"/>
+            <a:off x="5486400" y="822960"/>
+            <a:ext cx="3200400" cy="1800225"/>
           </a:xfrm>
           <a:prstGeom prst="rect">
             <a:avLst/>
@@ -4737,7 +4722,7 @@
         </p:nvSpPr>
         <p:spPr>
           <a:xfrm>
-            <a:off x="6652260" y="1467326"/>
+            <a:off x="6766560" y="1403032"/>
             <a:ext cx="640080" cy="640080"/>
           </a:xfrm>
           <a:prstGeom prst="ellipse">
@@ -4766,7 +4751,7 @@
         </p:nvSpPr>
         <p:spPr>
           <a:xfrm rot="5400000">
-            <a:off x="6880860" y="1641062"/>
+            <a:off x="6995160" y="1576769"/>
             <a:ext cx="256032" cy="292608"/>
           </a:xfrm>
           <a:prstGeom prst="triangle">
@@ -4791,8 +4776,8 @@
         </p:nvSpPr>
         <p:spPr>
           <a:xfrm>
-            <a:off x="5257800" y="2843213"/>
-            <a:ext cx="3429000" cy="548640"/>
+            <a:off x="5486400" y="2714625"/>
+            <a:ext cx="3200400" cy="548640"/>
           </a:xfrm>
           <a:prstGeom prst="rect">
             <a:avLst/>
@@ -4827,8 +4812,8 @@
         </p:nvSpPr>
         <p:spPr>
           <a:xfrm>
-            <a:off x="5257800" y="3566160"/>
-            <a:ext cx="3429000" cy="502920"/>
+            <a:off x="5486400" y="3566160"/>
+            <a:ext cx="3200400" cy="502920"/>
           </a:xfrm>
           <a:prstGeom prst="rect">
             <a:avLst/>
@@ -4945,8 +4930,8 @@
         </p:nvSpPr>
         <p:spPr>
           <a:xfrm>
-            <a:off x="457200" y="640080"/>
-            <a:ext cx="4160520" cy="1051560"/>
+            <a:off x="457200" y="594360"/>
+            <a:ext cx="4572000" cy="1143000"/>
           </a:xfrm>
           <a:prstGeom prst="rect">
             <a:avLst/>
@@ -4964,7 +4949,7 @@
               <a:buNone/>
             </a:pPr>
             <a:r>
-              <a:rPr lang="en-US" sz="2400" b="1" dirty="0">
+              <a:rPr lang="en-US" sz="2600" b="1" dirty="0">
                 <a:solidFill>
                   <a:schemeClr val="tx2"/>
                 </a:solidFill>
@@ -4974,7 +4959,7 @@
               </a:rPr>
               <a:t>Dunkelfabriken: Roboter bauen Roboter</a:t>
             </a:r>
-            <a:endParaRPr lang="en-US" sz="2400" dirty="0"/>
+            <a:endParaRPr lang="en-US" sz="2600" dirty="0"/>
           </a:p>
         </p:txBody>
       </p:sp>
@@ -4986,36 +4971,31 @@
         </p:nvSpPr>
         <p:spPr>
           <a:xfrm>
-            <a:off x="457200" y="1783080"/>
-            <a:ext cx="4160520" cy="2834640"/>
-          </a:xfrm>
-          <a:prstGeom prst="rect">
-            <a:avLst/>
-          </a:prstGeom>
-          <a:noFill/>
-          <a:ln/>
-        </p:spPr>
-        <p:txBody>
-          <a:bodyPr wrap="square" lIns="0" tIns="0" rIns="0" bIns="0" rtlCol="0" anchor="t">
-            <a:normAutofit/>
-          </a:bodyPr>
-          <a:lstStyle/>
-          <a:p>
-            <a:pPr indent="0" marL="0">
-              <a:spcAft>
-                <a:spcPts val="600"/>
-              </a:spcAft>
-              <a:buNone/>
-            </a:pPr>
-            <a:r>
-              <a:rPr lang="en-US" sz="1500" dirty="0">
+            <a:off x="457200" y="1828800"/>
+            <a:ext cx="4572000" cy="2834640"/>
+          </a:xfrm>
+          <a:prstGeom prst="rect">
+            <a:avLst/>
+          </a:prstGeom>
+          <a:noFill/>
+          <a:ln/>
+        </p:spPr>
+        <p:txBody>
+          <a:bodyPr wrap="square" lIns="0" tIns="0" rIns="0" bIns="0" rtlCol="0" anchor="t"/>
+          <a:lstStyle/>
+          <a:p>
+            <a:pPr indent="0" marL="0">
+              <a:buNone/>
+            </a:pPr>
+            <a:r>
+              <a:rPr lang="en-US" sz="2200" dirty="0">
                 <a:solidFill>
                   <a:schemeClr val="tx1"/>
                 </a:solidFill>
               </a:rPr>
               <a:t>In hochmodernen Werken wie in Liuzhou bauen humanoide Roboter bereits Tag und Nacht selbstständig neue Roboter zusammen. Für diese Maschinen wird in den sogenannten Dunkelfabriken überhaupt kein Licht mehr benötigt.</a:t>
             </a:r>
-            <a:endParaRPr lang="en-US" sz="1500" dirty="0"/>
+            <a:endParaRPr lang="en-US" sz="2200" dirty="0"/>
           </a:p>
         </p:txBody>
       </p:sp>
@@ -5063,8 +5043,8 @@
         </p:nvSpPr>
         <p:spPr>
           <a:xfrm>
-            <a:off x="5257800" y="822960"/>
-            <a:ext cx="3429000" cy="2651760"/>
+            <a:off x="5486400" y="822960"/>
+            <a:ext cx="3200400" cy="2651760"/>
           </a:xfrm>
           <a:prstGeom prst="roundRect">
             <a:avLst>
@@ -5090,8 +5070,8 @@
         </p:nvSpPr>
         <p:spPr>
           <a:xfrm>
-            <a:off x="5257800" y="960120"/>
-            <a:ext cx="3429000" cy="822960"/>
+            <a:off x="5486400" y="960120"/>
+            <a:ext cx="3200400" cy="822960"/>
           </a:xfrm>
           <a:prstGeom prst="rect">
             <a:avLst/>
@@ -5129,8 +5109,8 @@
         </p:nvSpPr>
         <p:spPr>
           <a:xfrm>
-            <a:off x="5486400" y="1874520"/>
-            <a:ext cx="2971800" cy="1463040"/>
+            <a:off x="5715000" y="1874520"/>
+            <a:ext cx="2743200" cy="1463040"/>
           </a:xfrm>
           <a:prstGeom prst="rect">
             <a:avLst/>
@@ -5165,8 +5145,8 @@
         </p:nvSpPr>
         <p:spPr>
           <a:xfrm>
-            <a:off x="5257800" y="3566160"/>
-            <a:ext cx="3429000" cy="228600"/>
+            <a:off x="5486400" y="3566160"/>
+            <a:ext cx="3200400" cy="228600"/>
           </a:xfrm>
           <a:prstGeom prst="rect">
             <a:avLst/>
@@ -5262,8 +5242,8 @@
         </p:nvSpPr>
         <p:spPr>
           <a:xfrm>
-            <a:off x="457200" y="640080"/>
-            <a:ext cx="4160520" cy="1051560"/>
+            <a:off x="457200" y="594360"/>
+            <a:ext cx="4572000" cy="1143000"/>
           </a:xfrm>
           <a:prstGeom prst="rect">
             <a:avLst/>
@@ -5281,7 +5261,7 @@
               <a:buNone/>
             </a:pPr>
             <a:r>
-              <a:rPr lang="en-US" sz="2400" b="1" dirty="0">
+              <a:rPr lang="en-US" sz="2600" b="1" dirty="0">
                 <a:solidFill>
                   <a:schemeClr val="tx2"/>
                 </a:solidFill>
@@ -5291,48 +5271,43 @@
               </a:rPr>
               <a:t>Tesla Optimus auf dem Montageband</a:t>
             </a:r>
+            <a:endParaRPr lang="en-US" sz="2600" dirty="0"/>
+          </a:p>
+        </p:txBody>
+      </p:sp>
+      <p:sp>
+        <p:nvSpPr>
+          <p:cNvPr id="4" name="Text"/>
+          <p:cNvSpPr txBox="1"/>
+          <p:nvPr/>
+        </p:nvSpPr>
+        <p:spPr>
+          <a:xfrm>
+            <a:off x="457200" y="1828800"/>
+            <a:ext cx="4572000" cy="2834640"/>
+          </a:xfrm>
+          <a:prstGeom prst="rect">
+            <a:avLst/>
+          </a:prstGeom>
+          <a:noFill/>
+          <a:ln/>
+        </p:spPr>
+        <p:txBody>
+          <a:bodyPr wrap="square" lIns="0" tIns="0" rIns="0" bIns="0" rtlCol="0" anchor="t"/>
+          <a:lstStyle/>
+          <a:p>
+            <a:pPr indent="0" marL="0">
+              <a:buNone/>
+            </a:pPr>
+            <a:r>
+              <a:rPr lang="en-US" sz="2400" dirty="0">
+                <a:solidFill>
+                  <a:schemeClr val="tx1"/>
+                </a:solidFill>
+              </a:rPr>
+              <a:t>In den Werken von Tesla wird der Roboter Optimus für wiederkehrende Aufgaben in der Produktion trainiert. Er sortiert schwere Batteriezellen und lernt direkt aus den Videos menschlicher Arbeiter.</a:t>
+            </a:r>
             <a:endParaRPr lang="en-US" sz="2400" dirty="0"/>
-          </a:p>
-        </p:txBody>
-      </p:sp>
-      <p:sp>
-        <p:nvSpPr>
-          <p:cNvPr id="4" name="Text"/>
-          <p:cNvSpPr txBox="1"/>
-          <p:nvPr/>
-        </p:nvSpPr>
-        <p:spPr>
-          <a:xfrm>
-            <a:off x="457200" y="1783080"/>
-            <a:ext cx="4160520" cy="2834640"/>
-          </a:xfrm>
-          <a:prstGeom prst="rect">
-            <a:avLst/>
-          </a:prstGeom>
-          <a:noFill/>
-          <a:ln/>
-        </p:spPr>
-        <p:txBody>
-          <a:bodyPr wrap="square" lIns="0" tIns="0" rIns="0" bIns="0" rtlCol="0" anchor="t">
-            <a:normAutofit/>
-          </a:bodyPr>
-          <a:lstStyle/>
-          <a:p>
-            <a:pPr indent="0" marL="0">
-              <a:spcAft>
-                <a:spcPts val="600"/>
-              </a:spcAft>
-              <a:buNone/>
-            </a:pPr>
-            <a:r>
-              <a:rPr lang="en-US" sz="1500" dirty="0">
-                <a:solidFill>
-                  <a:schemeClr val="tx1"/>
-                </a:solidFill>
-              </a:rPr>
-              <a:t>In den Werken von Tesla wird der Roboter Optimus für wiederkehrende Aufgaben in der Produktion trainiert. Er sortiert schwere Batteriezellen und lernt direkt aus den Videos menschlicher Arbeiter.</a:t>
-            </a:r>
-            <a:endParaRPr lang="en-US" sz="1500" dirty="0"/>
           </a:p>
         </p:txBody>
       </p:sp>
@@ -5388,8 +5363,8 @@
         </p:blipFill>
         <p:spPr>
           <a:xfrm>
-            <a:off x="5257800" y="457200"/>
-            <a:ext cx="3429000" cy="3611880"/>
+            <a:off x="5486400" y="457200"/>
+            <a:ext cx="3200400" cy="3374136"/>
           </a:xfrm>
           <a:prstGeom prst="rect">
             <a:avLst/>
@@ -5404,8 +5379,8 @@
         </p:nvSpPr>
         <p:spPr>
           <a:xfrm>
-            <a:off x="5257800" y="4114800"/>
-            <a:ext cx="3429000" cy="201168"/>
+            <a:off x="5486400" y="3886200"/>
+            <a:ext cx="3200400" cy="201168"/>
           </a:xfrm>
           <a:prstGeom prst="rect">
             <a:avLst/>
@@ -5440,8 +5415,8 @@
         </p:nvSpPr>
         <p:spPr>
           <a:xfrm>
-            <a:off x="5257800" y="4389120"/>
-            <a:ext cx="3429000" cy="502920"/>
+            <a:off x="5486400" y="4160520"/>
+            <a:ext cx="3200400" cy="502920"/>
           </a:xfrm>
           <a:prstGeom prst="rect">
             <a:avLst/>
@@ -5558,8 +5533,8 @@
         </p:nvSpPr>
         <p:spPr>
           <a:xfrm>
-            <a:off x="457200" y="640080"/>
-            <a:ext cx="4160520" cy="1051560"/>
+            <a:off x="457200" y="594360"/>
+            <a:ext cx="4572000" cy="1143000"/>
           </a:xfrm>
           <a:prstGeom prst="rect">
             <a:avLst/>
@@ -5577,7 +5552,7 @@
               <a:buNone/>
             </a:pPr>
             <a:r>
-              <a:rPr lang="en-US" sz="2400" b="1" dirty="0">
+              <a:rPr lang="en-US" sz="2600" b="1" dirty="0">
                 <a:solidFill>
                   <a:schemeClr val="tx2"/>
                 </a:solidFill>
@@ -5587,48 +5562,43 @@
               </a:rPr>
               <a:t>Qualitätskontrolle mit Computer Vision</a:t>
             </a:r>
+            <a:endParaRPr lang="en-US" sz="2600" dirty="0"/>
+          </a:p>
+        </p:txBody>
+      </p:sp>
+      <p:sp>
+        <p:nvSpPr>
+          <p:cNvPr id="4" name="Text"/>
+          <p:cNvSpPr txBox="1"/>
+          <p:nvPr/>
+        </p:nvSpPr>
+        <p:spPr>
+          <a:xfrm>
+            <a:off x="457200" y="1828800"/>
+            <a:ext cx="4572000" cy="2834640"/>
+          </a:xfrm>
+          <a:prstGeom prst="rect">
+            <a:avLst/>
+          </a:prstGeom>
+          <a:noFill/>
+          <a:ln/>
+        </p:spPr>
+        <p:txBody>
+          <a:bodyPr wrap="square" lIns="0" tIns="0" rIns="0" bIns="0" rtlCol="0" anchor="t"/>
+          <a:lstStyle/>
+          <a:p>
+            <a:pPr indent="0" marL="0">
+              <a:buNone/>
+            </a:pPr>
+            <a:r>
+              <a:rPr lang="en-US" sz="2400" dirty="0">
+                <a:solidFill>
+                  <a:schemeClr val="tx1"/>
+                </a:solidFill>
+              </a:rPr>
+              <a:t>Roboter prüfen frisch produzierte Karosserieteile mit Kameras und Laserstrahlen auf Fehler. Sie entdecken winzige Kratzer im Lack schneller und gründlicher als das menschliche Auge.</a:t>
+            </a:r>
             <a:endParaRPr lang="en-US" sz="2400" dirty="0"/>
-          </a:p>
-        </p:txBody>
-      </p:sp>
-      <p:sp>
-        <p:nvSpPr>
-          <p:cNvPr id="4" name="Text"/>
-          <p:cNvSpPr txBox="1"/>
-          <p:nvPr/>
-        </p:nvSpPr>
-        <p:spPr>
-          <a:xfrm>
-            <a:off x="457200" y="1783080"/>
-            <a:ext cx="4160520" cy="2834640"/>
-          </a:xfrm>
-          <a:prstGeom prst="rect">
-            <a:avLst/>
-          </a:prstGeom>
-          <a:noFill/>
-          <a:ln/>
-        </p:spPr>
-        <p:txBody>
-          <a:bodyPr wrap="square" lIns="0" tIns="0" rIns="0" bIns="0" rtlCol="0" anchor="t">
-            <a:normAutofit/>
-          </a:bodyPr>
-          <a:lstStyle/>
-          <a:p>
-            <a:pPr indent="0" marL="0">
-              <a:spcAft>
-                <a:spcPts val="600"/>
-              </a:spcAft>
-              <a:buNone/>
-            </a:pPr>
-            <a:r>
-              <a:rPr lang="en-US" sz="1500" dirty="0">
-                <a:solidFill>
-                  <a:schemeClr val="tx1"/>
-                </a:solidFill>
-              </a:rPr>
-              <a:t>Roboter prüfen frisch produzierte Karosserieteile mit Kameras und Laserstrahlen auf Fehler. Sie entdecken winzige Kratzer im Lack schneller und gründlicher als das menschliche Auge.</a:t>
-            </a:r>
-            <a:endParaRPr lang="en-US" sz="1500" dirty="0"/>
           </a:p>
         </p:txBody>
       </p:sp>
@@ -5676,8 +5646,8 @@
         </p:nvSpPr>
         <p:spPr>
           <a:xfrm>
-            <a:off x="5257800" y="822960"/>
-            <a:ext cx="3429000" cy="2651760"/>
+            <a:off x="5486400" y="822960"/>
+            <a:ext cx="3200400" cy="2651760"/>
           </a:xfrm>
           <a:prstGeom prst="roundRect">
             <a:avLst>
@@ -5703,8 +5673,8 @@
         </p:nvSpPr>
         <p:spPr>
           <a:xfrm>
-            <a:off x="5257800" y="960120"/>
-            <a:ext cx="3429000" cy="822960"/>
+            <a:off x="5486400" y="960120"/>
+            <a:ext cx="3200400" cy="822960"/>
           </a:xfrm>
           <a:prstGeom prst="rect">
             <a:avLst/>
@@ -5742,8 +5712,8 @@
         </p:nvSpPr>
         <p:spPr>
           <a:xfrm>
-            <a:off x="5486400" y="1874520"/>
-            <a:ext cx="2971800" cy="1463040"/>
+            <a:off x="5715000" y="1874520"/>
+            <a:ext cx="2743200" cy="1463040"/>
           </a:xfrm>
           <a:prstGeom prst="rect">
             <a:avLst/>
@@ -5778,8 +5748,8 @@
         </p:nvSpPr>
         <p:spPr>
           <a:xfrm>
-            <a:off x="5257800" y="3566160"/>
-            <a:ext cx="3429000" cy="228600"/>
+            <a:off x="5486400" y="3566160"/>
+            <a:ext cx="3200400" cy="228600"/>
           </a:xfrm>
           <a:prstGeom prst="rect">
             <a:avLst/>
@@ -5875,8 +5845,8 @@
         </p:nvSpPr>
         <p:spPr>
           <a:xfrm>
-            <a:off x="457200" y="640080"/>
-            <a:ext cx="4160520" cy="1051560"/>
+            <a:off x="457200" y="594360"/>
+            <a:ext cx="4572000" cy="1143000"/>
           </a:xfrm>
           <a:prstGeom prst="rect">
             <a:avLst/>
@@ -5894,7 +5864,7 @@
               <a:buNone/>
             </a:pPr>
             <a:r>
-              <a:rPr lang="en-US" sz="2400" b="1" dirty="0">
+              <a:rPr lang="en-US" sz="2600" b="1" dirty="0">
                 <a:solidFill>
                   <a:schemeClr val="tx2"/>
                 </a:solidFill>
@@ -5904,7 +5874,7 @@
               </a:rPr>
               <a:t>Figure 02 und Schwerlasttransport</a:t>
             </a:r>
-            <a:endParaRPr lang="en-US" sz="2400" dirty="0"/>
+            <a:endParaRPr lang="en-US" sz="2600" dirty="0"/>
           </a:p>
         </p:txBody>
       </p:sp>
@@ -5916,36 +5886,31 @@
         </p:nvSpPr>
         <p:spPr>
           <a:xfrm>
-            <a:off x="457200" y="1783080"/>
-            <a:ext cx="4160520" cy="2834640"/>
-          </a:xfrm>
-          <a:prstGeom prst="rect">
-            <a:avLst/>
-          </a:prstGeom>
-          <a:noFill/>
-          <a:ln/>
-        </p:spPr>
-        <p:txBody>
-          <a:bodyPr wrap="square" lIns="0" tIns="0" rIns="0" bIns="0" rtlCol="0" anchor="t">
-            <a:normAutofit/>
-          </a:bodyPr>
-          <a:lstStyle/>
-          <a:p>
-            <a:pPr indent="0" marL="0">
-              <a:spcAft>
-                <a:spcPts val="600"/>
-              </a:spcAft>
-              <a:buNone/>
-            </a:pPr>
-            <a:r>
-              <a:rPr lang="en-US" sz="1500" dirty="0">
+            <a:off x="457200" y="1828800"/>
+            <a:ext cx="4572000" cy="2834640"/>
+          </a:xfrm>
+          <a:prstGeom prst="rect">
+            <a:avLst/>
+          </a:prstGeom>
+          <a:noFill/>
+          <a:ln/>
+        </p:spPr>
+        <p:txBody>
+          <a:bodyPr wrap="square" lIns="0" tIns="0" rIns="0" bIns="0" rtlCol="0" anchor="t"/>
+          <a:lstStyle/>
+          <a:p>
+            <a:pPr indent="0" marL="0">
+              <a:buNone/>
+            </a:pPr>
+            <a:r>
+              <a:rPr lang="en-US" sz="2100" dirty="0">
                 <a:solidFill>
                   <a:schemeClr val="tx1"/>
                 </a:solidFill>
               </a:rPr>
               <a:t>Fortschrittliche Roboter wie Figure 02 platzieren bei Autobauern schwere Bauteile mit höchster Präzision in Schweißvorrichtungen. Sie nutzen beim Transport durch die Werkshallen dieselben Wege und Treppen, die ursprünglich für Menschen gebaut wurden.</a:t>
             </a:r>
-            <a:endParaRPr lang="en-US" sz="1500" dirty="0"/>
+            <a:endParaRPr lang="en-US" sz="2100" dirty="0"/>
           </a:p>
         </p:txBody>
       </p:sp>
@@ -5993,8 +5958,8 @@
         </p:nvSpPr>
         <p:spPr>
           <a:xfrm>
-            <a:off x="5257800" y="822960"/>
-            <a:ext cx="3429000" cy="2651760"/>
+            <a:off x="5486400" y="822960"/>
+            <a:ext cx="3200400" cy="2651760"/>
           </a:xfrm>
           <a:prstGeom prst="roundRect">
             <a:avLst>
@@ -6020,8 +5985,8 @@
         </p:nvSpPr>
         <p:spPr>
           <a:xfrm>
-            <a:off x="5257800" y="960120"/>
-            <a:ext cx="3429000" cy="822960"/>
+            <a:off x="5486400" y="960120"/>
+            <a:ext cx="3200400" cy="822960"/>
           </a:xfrm>
           <a:prstGeom prst="rect">
             <a:avLst/>
@@ -6059,8 +6024,8 @@
         </p:nvSpPr>
         <p:spPr>
           <a:xfrm>
-            <a:off x="5486400" y="1874520"/>
-            <a:ext cx="2971800" cy="1463040"/>
+            <a:off x="5715000" y="1874520"/>
+            <a:ext cx="2743200" cy="1463040"/>
           </a:xfrm>
           <a:prstGeom prst="rect">
             <a:avLst/>
@@ -6095,8 +6060,8 @@
         </p:nvSpPr>
         <p:spPr>
           <a:xfrm>
-            <a:off x="5257800" y="3566160"/>
-            <a:ext cx="3429000" cy="228600"/>
+            <a:off x="5486400" y="3566160"/>
+            <a:ext cx="3200400" cy="228600"/>
           </a:xfrm>
           <a:prstGeom prst="rect">
             <a:avLst/>
@@ -6192,8 +6157,8 @@
         </p:nvSpPr>
         <p:spPr>
           <a:xfrm>
-            <a:off x="457200" y="640080"/>
-            <a:ext cx="4160520" cy="1051560"/>
+            <a:off x="457200" y="594360"/>
+            <a:ext cx="4572000" cy="1143000"/>
           </a:xfrm>
           <a:prstGeom prst="rect">
             <a:avLst/>
@@ -6211,7 +6176,7 @@
               <a:buNone/>
             </a:pPr>
             <a:r>
-              <a:rPr lang="en-US" sz="2400" b="1" dirty="0">
+              <a:rPr lang="en-US" sz="2600" b="1" dirty="0">
                 <a:solidFill>
                   <a:schemeClr val="tx2"/>
                 </a:solidFill>
@@ -6221,48 +6186,43 @@
               </a:rPr>
               <a:t>Autonomes Laden und Akkuwechsel</a:t>
             </a:r>
+            <a:endParaRPr lang="en-US" sz="2600" dirty="0"/>
+          </a:p>
+        </p:txBody>
+      </p:sp>
+      <p:sp>
+        <p:nvSpPr>
+          <p:cNvPr id="4" name="Text"/>
+          <p:cNvSpPr txBox="1"/>
+          <p:nvPr/>
+        </p:nvSpPr>
+        <p:spPr>
+          <a:xfrm>
+            <a:off x="457200" y="1828800"/>
+            <a:ext cx="4572000" cy="2834640"/>
+          </a:xfrm>
+          <a:prstGeom prst="rect">
+            <a:avLst/>
+          </a:prstGeom>
+          <a:noFill/>
+          <a:ln/>
+        </p:spPr>
+        <p:txBody>
+          <a:bodyPr wrap="square" lIns="0" tIns="0" rIns="0" bIns="0" rtlCol="0" anchor="t"/>
+          <a:lstStyle/>
+          <a:p>
+            <a:pPr indent="0" marL="0">
+              <a:buNone/>
+            </a:pPr>
+            <a:r>
+              <a:rPr lang="en-US" sz="2400" dirty="0">
+                <a:solidFill>
+                  <a:schemeClr val="tx1"/>
+                </a:solidFill>
+              </a:rPr>
+              <a:t>Wenn die Batterie leer wird, laufen Fabrikroboter selbständig zu ihrer Ladestation zurück. Einige Industrieroboter können ihre Akkus sogar in wenigen Minuten gegenseitig austauschen.</a:t>
+            </a:r>
             <a:endParaRPr lang="en-US" sz="2400" dirty="0"/>
-          </a:p>
-        </p:txBody>
-      </p:sp>
-      <p:sp>
-        <p:nvSpPr>
-          <p:cNvPr id="4" name="Text"/>
-          <p:cNvSpPr txBox="1"/>
-          <p:nvPr/>
-        </p:nvSpPr>
-        <p:spPr>
-          <a:xfrm>
-            <a:off x="457200" y="1783080"/>
-            <a:ext cx="4160520" cy="2834640"/>
-          </a:xfrm>
-          <a:prstGeom prst="rect">
-            <a:avLst/>
-          </a:prstGeom>
-          <a:noFill/>
-          <a:ln/>
-        </p:spPr>
-        <p:txBody>
-          <a:bodyPr wrap="square" lIns="0" tIns="0" rIns="0" bIns="0" rtlCol="0" anchor="t">
-            <a:normAutofit/>
-          </a:bodyPr>
-          <a:lstStyle/>
-          <a:p>
-            <a:pPr indent="0" marL="0">
-              <a:spcAft>
-                <a:spcPts val="600"/>
-              </a:spcAft>
-              <a:buNone/>
-            </a:pPr>
-            <a:r>
-              <a:rPr lang="en-US" sz="1500" dirty="0">
-                <a:solidFill>
-                  <a:schemeClr val="tx1"/>
-                </a:solidFill>
-              </a:rPr>
-              <a:t>Wenn die Batterie leer wird, laufen Fabrikroboter selbständig zu ihrer Ladestation zurück. Einige Industrieroboter können ihre Akkus sogar in wenigen Minuten gegenseitig austauschen.</a:t>
-            </a:r>
-            <a:endParaRPr lang="en-US" sz="1500" dirty="0"/>
           </a:p>
         </p:txBody>
       </p:sp>
@@ -6310,8 +6270,8 @@
         </p:nvSpPr>
         <p:spPr>
           <a:xfrm>
-            <a:off x="5257800" y="822960"/>
-            <a:ext cx="3429000" cy="2651760"/>
+            <a:off x="5486400" y="822960"/>
+            <a:ext cx="3200400" cy="2651760"/>
           </a:xfrm>
           <a:prstGeom prst="roundRect">
             <a:avLst>
@@ -6337,8 +6297,8 @@
         </p:nvSpPr>
         <p:spPr>
           <a:xfrm>
-            <a:off x="5257800" y="960120"/>
-            <a:ext cx="3429000" cy="822960"/>
+            <a:off x="5486400" y="960120"/>
+            <a:ext cx="3200400" cy="822960"/>
           </a:xfrm>
           <a:prstGeom prst="rect">
             <a:avLst/>
@@ -6376,8 +6336,8 @@
         </p:nvSpPr>
         <p:spPr>
           <a:xfrm>
-            <a:off x="5486400" y="1874520"/>
-            <a:ext cx="2971800" cy="1463040"/>
+            <a:off x="5715000" y="1874520"/>
+            <a:ext cx="2743200" cy="1463040"/>
           </a:xfrm>
           <a:prstGeom prst="rect">
             <a:avLst/>
@@ -6412,8 +6372,8 @@
         </p:nvSpPr>
         <p:spPr>
           <a:xfrm>
-            <a:off x="5257800" y="3566160"/>
-            <a:ext cx="3429000" cy="228600"/>
+            <a:off x="5486400" y="3566160"/>
+            <a:ext cx="3200400" cy="228600"/>
           </a:xfrm>
           <a:prstGeom prst="rect">
             <a:avLst/>
@@ -6509,8 +6469,8 @@
         </p:nvSpPr>
         <p:spPr>
           <a:xfrm>
-            <a:off x="457200" y="640080"/>
-            <a:ext cx="4160520" cy="1051560"/>
+            <a:off x="457200" y="594360"/>
+            <a:ext cx="4572000" cy="1143000"/>
           </a:xfrm>
           <a:prstGeom prst="rect">
             <a:avLst/>
@@ -6528,7 +6488,7 @@
               <a:buNone/>
             </a:pPr>
             <a:r>
-              <a:rPr lang="en-US" sz="2400" b="1" dirty="0">
+              <a:rPr lang="en-US" sz="2600" b="1" dirty="0">
                 <a:solidFill>
                   <a:schemeClr val="tx2"/>
                 </a:solidFill>
@@ -6538,48 +6498,43 @@
               </a:rPr>
               <a:t>Globaler Wettbewerb in der Fertigung</a:t>
             </a:r>
+            <a:endParaRPr lang="en-US" sz="2600" dirty="0"/>
+          </a:p>
+        </p:txBody>
+      </p:sp>
+      <p:sp>
+        <p:nvSpPr>
+          <p:cNvPr id="4" name="Text"/>
+          <p:cNvSpPr txBox="1"/>
+          <p:nvPr/>
+        </p:nvSpPr>
+        <p:spPr>
+          <a:xfrm>
+            <a:off x="457200" y="1828800"/>
+            <a:ext cx="4572000" cy="2834640"/>
+          </a:xfrm>
+          <a:prstGeom prst="rect">
+            <a:avLst/>
+          </a:prstGeom>
+          <a:noFill/>
+          <a:ln/>
+        </p:spPr>
+        <p:txBody>
+          <a:bodyPr wrap="square" lIns="0" tIns="0" rIns="0" bIns="0" rtlCol="0" anchor="t"/>
+          <a:lstStyle/>
+          <a:p>
+            <a:pPr indent="0" marL="0">
+              <a:buNone/>
+            </a:pPr>
+            <a:r>
+              <a:rPr lang="en-US" sz="2400" dirty="0">
+                <a:solidFill>
+                  <a:schemeClr val="tx1"/>
+                </a:solidFill>
+              </a:rPr>
+              <a:t>Länder wie China, die USA und Deutschland investieren Milliarden in die heimische Roboterindustrie. Die Automatisierung gilt als wichtigster Schlüssel zur Bewältigung des Arbeitskräftemangels.</a:t>
+            </a:r>
             <a:endParaRPr lang="en-US" sz="2400" dirty="0"/>
-          </a:p>
-        </p:txBody>
-      </p:sp>
-      <p:sp>
-        <p:nvSpPr>
-          <p:cNvPr id="4" name="Text"/>
-          <p:cNvSpPr txBox="1"/>
-          <p:nvPr/>
-        </p:nvSpPr>
-        <p:spPr>
-          <a:xfrm>
-            <a:off x="457200" y="1783080"/>
-            <a:ext cx="4160520" cy="2834640"/>
-          </a:xfrm>
-          <a:prstGeom prst="rect">
-            <a:avLst/>
-          </a:prstGeom>
-          <a:noFill/>
-          <a:ln/>
-        </p:spPr>
-        <p:txBody>
-          <a:bodyPr wrap="square" lIns="0" tIns="0" rIns="0" bIns="0" rtlCol="0" anchor="t">
-            <a:normAutofit/>
-          </a:bodyPr>
-          <a:lstStyle/>
-          <a:p>
-            <a:pPr indent="0" marL="0">
-              <a:spcAft>
-                <a:spcPts val="600"/>
-              </a:spcAft>
-              <a:buNone/>
-            </a:pPr>
-            <a:r>
-              <a:rPr lang="en-US" sz="1500" dirty="0">
-                <a:solidFill>
-                  <a:schemeClr val="tx1"/>
-                </a:solidFill>
-              </a:rPr>
-              <a:t>Länder wie China, die USA und Deutschland investieren Milliarden in die heimische Roboterindustrie. Die Automatisierung gilt als wichtigster Schlüssel zur Bewältigung des Arbeitskräftemangels.</a:t>
-            </a:r>
-            <a:endParaRPr lang="en-US" sz="1500" dirty="0"/>
           </a:p>
         </p:txBody>
       </p:sp>
@@ -6627,8 +6582,8 @@
         </p:nvSpPr>
         <p:spPr>
           <a:xfrm>
-            <a:off x="5257800" y="822960"/>
-            <a:ext cx="3429000" cy="2651760"/>
+            <a:off x="5486400" y="822960"/>
+            <a:ext cx="3200400" cy="2651760"/>
           </a:xfrm>
           <a:prstGeom prst="roundRect">
             <a:avLst>
@@ -6654,8 +6609,8 @@
         </p:nvSpPr>
         <p:spPr>
           <a:xfrm>
-            <a:off x="5257800" y="960120"/>
-            <a:ext cx="3429000" cy="822960"/>
+            <a:off x="5486400" y="960120"/>
+            <a:ext cx="3200400" cy="822960"/>
           </a:xfrm>
           <a:prstGeom prst="rect">
             <a:avLst/>
@@ -6693,8 +6648,8 @@
         </p:nvSpPr>
         <p:spPr>
           <a:xfrm>
-            <a:off x="5486400" y="1874520"/>
-            <a:ext cx="2971800" cy="1463040"/>
+            <a:off x="5715000" y="1874520"/>
+            <a:ext cx="2743200" cy="1463040"/>
           </a:xfrm>
           <a:prstGeom prst="rect">
             <a:avLst/>
@@ -6729,8 +6684,8 @@
         </p:nvSpPr>
         <p:spPr>
           <a:xfrm>
-            <a:off x="5257800" y="3566160"/>
-            <a:ext cx="3429000" cy="228600"/>
+            <a:off x="5486400" y="3566160"/>
+            <a:ext cx="3200400" cy="228600"/>
           </a:xfrm>
           <a:prstGeom prst="rect">
             <a:avLst/>
@@ -6826,8 +6781,8 @@
         </p:nvSpPr>
         <p:spPr>
           <a:xfrm>
-            <a:off x="457200" y="640080"/>
-            <a:ext cx="4160520" cy="1051560"/>
+            <a:off x="457200" y="594360"/>
+            <a:ext cx="4572000" cy="1143000"/>
           </a:xfrm>
           <a:prstGeom prst="rect">
             <a:avLst/>
@@ -6845,7 +6800,7 @@
               <a:buNone/>
             </a:pPr>
             <a:r>
-              <a:rPr lang="en-US" sz="2400" b="1" dirty="0">
+              <a:rPr lang="en-US" sz="2600" b="1" dirty="0">
                 <a:solidFill>
                   <a:schemeClr val="tx2"/>
                 </a:solidFill>
@@ -6855,48 +6810,43 @@
               </a:rPr>
               <a:t>Das Gehirn: Multimodale KI-Modelle</a:t>
             </a:r>
+            <a:endParaRPr lang="en-US" sz="2600" dirty="0"/>
+          </a:p>
+        </p:txBody>
+      </p:sp>
+      <p:sp>
+        <p:nvSpPr>
+          <p:cNvPr id="4" name="Text"/>
+          <p:cNvSpPr txBox="1"/>
+          <p:nvPr/>
+        </p:nvSpPr>
+        <p:spPr>
+          <a:xfrm>
+            <a:off x="457200" y="1828800"/>
+            <a:ext cx="4572000" cy="2834640"/>
+          </a:xfrm>
+          <a:prstGeom prst="rect">
+            <a:avLst/>
+          </a:prstGeom>
+          <a:noFill/>
+          <a:ln/>
+        </p:spPr>
+        <p:txBody>
+          <a:bodyPr wrap="square" lIns="0" tIns="0" rIns="0" bIns="0" rtlCol="0" anchor="t"/>
+          <a:lstStyle/>
+          <a:p>
+            <a:pPr indent="0" marL="0">
+              <a:buNone/>
+            </a:pPr>
+            <a:r>
+              <a:rPr lang="en-US" sz="2400" dirty="0">
+                <a:solidFill>
+                  <a:schemeClr val="tx1"/>
+                </a:solidFill>
+              </a:rPr>
+              <a:t>Moderne Humanoide werden von Modellen gesteuert, die Sprache, Kameras und Sensoren kombinieren. Dadurch verstehen sie normale Sprachbefehle und planen Handlungen eigenständig im Raum.</a:t>
+            </a:r>
             <a:endParaRPr lang="en-US" sz="2400" dirty="0"/>
-          </a:p>
-        </p:txBody>
-      </p:sp>
-      <p:sp>
-        <p:nvSpPr>
-          <p:cNvPr id="4" name="Text"/>
-          <p:cNvSpPr txBox="1"/>
-          <p:nvPr/>
-        </p:nvSpPr>
-        <p:spPr>
-          <a:xfrm>
-            <a:off x="457200" y="1783080"/>
-            <a:ext cx="4160520" cy="2834640"/>
-          </a:xfrm>
-          <a:prstGeom prst="rect">
-            <a:avLst/>
-          </a:prstGeom>
-          <a:noFill/>
-          <a:ln/>
-        </p:spPr>
-        <p:txBody>
-          <a:bodyPr wrap="square" lIns="0" tIns="0" rIns="0" bIns="0" rtlCol="0" anchor="t">
-            <a:normAutofit/>
-          </a:bodyPr>
-          <a:lstStyle/>
-          <a:p>
-            <a:pPr indent="0" marL="0">
-              <a:spcAft>
-                <a:spcPts val="600"/>
-              </a:spcAft>
-              <a:buNone/>
-            </a:pPr>
-            <a:r>
-              <a:rPr lang="en-US" sz="1500" dirty="0">
-                <a:solidFill>
-                  <a:schemeClr val="tx1"/>
-                </a:solidFill>
-              </a:rPr>
-              <a:t>Moderne Humanoide werden von Modellen gesteuert, die Sprache, Kameras und Sensoren kombinieren. Dadurch verstehen sie normale Sprachbefehle und planen Handlungen eigenständig im Raum.</a:t>
-            </a:r>
-            <a:endParaRPr lang="en-US" sz="1500" dirty="0"/>
           </a:p>
         </p:txBody>
       </p:sp>
@@ -6944,8 +6894,8 @@
         </p:nvSpPr>
         <p:spPr>
           <a:xfrm>
-            <a:off x="5257800" y="822960"/>
-            <a:ext cx="3429000" cy="2651760"/>
+            <a:off x="5486400" y="822960"/>
+            <a:ext cx="3200400" cy="2651760"/>
           </a:xfrm>
           <a:prstGeom prst="roundRect">
             <a:avLst>
@@ -6971,8 +6921,8 @@
         </p:nvSpPr>
         <p:spPr>
           <a:xfrm>
-            <a:off x="5257800" y="960120"/>
-            <a:ext cx="3429000" cy="822960"/>
+            <a:off x="5486400" y="960120"/>
+            <a:ext cx="3200400" cy="822960"/>
           </a:xfrm>
           <a:prstGeom prst="rect">
             <a:avLst/>
@@ -7010,8 +6960,8 @@
         </p:nvSpPr>
         <p:spPr>
           <a:xfrm>
-            <a:off x="5486400" y="1874520"/>
-            <a:ext cx="2971800" cy="1463040"/>
+            <a:off x="5715000" y="1874520"/>
+            <a:ext cx="2743200" cy="1463040"/>
           </a:xfrm>
           <a:prstGeom prst="rect">
             <a:avLst/>
@@ -7046,8 +6996,8 @@
         </p:nvSpPr>
         <p:spPr>
           <a:xfrm>
-            <a:off x="5257800" y="3566160"/>
-            <a:ext cx="3429000" cy="228600"/>
+            <a:off x="5486400" y="3566160"/>
+            <a:ext cx="3200400" cy="228600"/>
           </a:xfrm>
           <a:prstGeom prst="rect">
             <a:avLst/>
@@ -7143,8 +7093,8 @@
         </p:nvSpPr>
         <p:spPr>
           <a:xfrm>
-            <a:off x="457200" y="640080"/>
-            <a:ext cx="4160520" cy="1051560"/>
+            <a:off x="457200" y="594360"/>
+            <a:ext cx="4572000" cy="1143000"/>
           </a:xfrm>
           <a:prstGeom prst="rect">
             <a:avLst/>
@@ -7162,7 +7112,7 @@
               <a:buNone/>
             </a:pPr>
             <a:r>
-              <a:rPr lang="en-US" sz="2400" b="1" dirty="0">
+              <a:rPr lang="en-US" sz="2600" b="1" dirty="0">
                 <a:solidFill>
                   <a:schemeClr val="tx2"/>
                 </a:solidFill>
@@ -7172,48 +7122,43 @@
               </a:rPr>
               <a:t>Die Evolution der humanoiden Roboter</a:t>
             </a:r>
+            <a:endParaRPr lang="en-US" sz="2600" dirty="0"/>
+          </a:p>
+        </p:txBody>
+      </p:sp>
+      <p:sp>
+        <p:nvSpPr>
+          <p:cNvPr id="4" name="Text"/>
+          <p:cNvSpPr txBox="1"/>
+          <p:nvPr/>
+        </p:nvSpPr>
+        <p:spPr>
+          <a:xfrm>
+            <a:off x="457200" y="1828800"/>
+            <a:ext cx="4572000" cy="2834640"/>
+          </a:xfrm>
+          <a:prstGeom prst="rect">
+            <a:avLst/>
+          </a:prstGeom>
+          <a:noFill/>
+          <a:ln/>
+        </p:spPr>
+        <p:txBody>
+          <a:bodyPr wrap="square" lIns="0" tIns="0" rIns="0" bIns="0" rtlCol="0" anchor="t"/>
+          <a:lstStyle/>
+          <a:p>
+            <a:pPr indent="0" marL="0">
+              <a:buNone/>
+            </a:pPr>
+            <a:r>
+              <a:rPr lang="en-US" sz="2400" dirty="0">
+                <a:solidFill>
+                  <a:schemeClr val="tx1"/>
+                </a:solidFill>
+              </a:rPr>
+              <a:t>Humanoide Roboter faszinieren die Menschheit seit vielen Jahrhunderten. Heute entwickeln sie sich dank künstlicher Intelligenz schneller als jemals zuvor.</a:t>
+            </a:r>
             <a:endParaRPr lang="en-US" sz="2400" dirty="0"/>
-          </a:p>
-        </p:txBody>
-      </p:sp>
-      <p:sp>
-        <p:nvSpPr>
-          <p:cNvPr id="4" name="Text"/>
-          <p:cNvSpPr txBox="1"/>
-          <p:nvPr/>
-        </p:nvSpPr>
-        <p:spPr>
-          <a:xfrm>
-            <a:off x="457200" y="1783080"/>
-            <a:ext cx="4160520" cy="2834640"/>
-          </a:xfrm>
-          <a:prstGeom prst="rect">
-            <a:avLst/>
-          </a:prstGeom>
-          <a:noFill/>
-          <a:ln/>
-        </p:spPr>
-        <p:txBody>
-          <a:bodyPr wrap="square" lIns="0" tIns="0" rIns="0" bIns="0" rtlCol="0" anchor="t">
-            <a:normAutofit/>
-          </a:bodyPr>
-          <a:lstStyle/>
-          <a:p>
-            <a:pPr indent="0" marL="0">
-              <a:spcAft>
-                <a:spcPts val="600"/>
-              </a:spcAft>
-              <a:buNone/>
-            </a:pPr>
-            <a:r>
-              <a:rPr lang="en-US" sz="1500" dirty="0">
-                <a:solidFill>
-                  <a:schemeClr val="tx1"/>
-                </a:solidFill>
-              </a:rPr>
-              <a:t>Humanoide Roboter faszinieren die Menschheit seit vielen Jahrhunderten. Heute entwickeln sie sich dank künstlicher Intelligenz schneller als jemals zuvor.</a:t>
-            </a:r>
-            <a:endParaRPr lang="en-US" sz="1500" dirty="0"/>
           </a:p>
         </p:txBody>
       </p:sp>
@@ -7269,8 +7214,8 @@
         </p:blipFill>
         <p:spPr>
           <a:xfrm>
-            <a:off x="5257800" y="457200"/>
-            <a:ext cx="3429000" cy="3611880"/>
+            <a:off x="5486400" y="457200"/>
+            <a:ext cx="3200400" cy="3374136"/>
           </a:xfrm>
           <a:prstGeom prst="rect">
             <a:avLst/>
@@ -7285,8 +7230,8 @@
         </p:nvSpPr>
         <p:spPr>
           <a:xfrm>
-            <a:off x="5257800" y="4114800"/>
-            <a:ext cx="3429000" cy="201168"/>
+            <a:off x="5486400" y="3886200"/>
+            <a:ext cx="3200400" cy="201168"/>
           </a:xfrm>
           <a:prstGeom prst="rect">
             <a:avLst/>
@@ -7382,8 +7327,8 @@
         </p:nvSpPr>
         <p:spPr>
           <a:xfrm>
-            <a:off x="457200" y="640080"/>
-            <a:ext cx="4160520" cy="1051560"/>
+            <a:off x="457200" y="594360"/>
+            <a:ext cx="4572000" cy="1143000"/>
           </a:xfrm>
           <a:prstGeom prst="rect">
             <a:avLst/>
@@ -7401,7 +7346,7 @@
               <a:buNone/>
             </a:pPr>
             <a:r>
-              <a:rPr lang="en-US" sz="2400" b="1" dirty="0">
+              <a:rPr lang="en-US" sz="2600" b="1" dirty="0">
                 <a:solidFill>
                   <a:schemeClr val="tx2"/>
                 </a:solidFill>
@@ -7411,48 +7356,43 @@
               </a:rPr>
               <a:t>Taktile Hände und Feingefühl</a:t>
             </a:r>
+            <a:endParaRPr lang="en-US" sz="2600" dirty="0"/>
+          </a:p>
+        </p:txBody>
+      </p:sp>
+      <p:sp>
+        <p:nvSpPr>
+          <p:cNvPr id="4" name="Text"/>
+          <p:cNvSpPr txBox="1"/>
+          <p:nvPr/>
+        </p:nvSpPr>
+        <p:spPr>
+          <a:xfrm>
+            <a:off x="457200" y="1828800"/>
+            <a:ext cx="4572000" cy="2834640"/>
+          </a:xfrm>
+          <a:prstGeom prst="rect">
+            <a:avLst/>
+          </a:prstGeom>
+          <a:noFill/>
+          <a:ln/>
+        </p:spPr>
+        <p:txBody>
+          <a:bodyPr wrap="square" lIns="0" tIns="0" rIns="0" bIns="0" rtlCol="0" anchor="t"/>
+          <a:lstStyle/>
+          <a:p>
+            <a:pPr indent="0" marL="0">
+              <a:buNone/>
+            </a:pPr>
+            <a:r>
+              <a:rPr lang="en-US" sz="2400" dirty="0">
+                <a:solidFill>
+                  <a:schemeClr val="tx1"/>
+                </a:solidFill>
+              </a:rPr>
+              <a:t>Bionische Hände besitzen heute bis zu zwanzig bewegliche Gelenke und weiche Drucksensoren. Damit kann ein Roboter ein zerbrechliches Ei sicher halten, ohne die Schale einzudrücken.</a:t>
+            </a:r>
             <a:endParaRPr lang="en-US" sz="2400" dirty="0"/>
-          </a:p>
-        </p:txBody>
-      </p:sp>
-      <p:sp>
-        <p:nvSpPr>
-          <p:cNvPr id="4" name="Text"/>
-          <p:cNvSpPr txBox="1"/>
-          <p:nvPr/>
-        </p:nvSpPr>
-        <p:spPr>
-          <a:xfrm>
-            <a:off x="457200" y="1783080"/>
-            <a:ext cx="4160520" cy="2834640"/>
-          </a:xfrm>
-          <a:prstGeom prst="rect">
-            <a:avLst/>
-          </a:prstGeom>
-          <a:noFill/>
-          <a:ln/>
-        </p:spPr>
-        <p:txBody>
-          <a:bodyPr wrap="square" lIns="0" tIns="0" rIns="0" bIns="0" rtlCol="0" anchor="t">
-            <a:normAutofit/>
-          </a:bodyPr>
-          <a:lstStyle/>
-          <a:p>
-            <a:pPr indent="0" marL="0">
-              <a:spcAft>
-                <a:spcPts val="600"/>
-              </a:spcAft>
-              <a:buNone/>
-            </a:pPr>
-            <a:r>
-              <a:rPr lang="en-US" sz="1500" dirty="0">
-                <a:solidFill>
-                  <a:schemeClr val="tx1"/>
-                </a:solidFill>
-              </a:rPr>
-              <a:t>Bionische Hände besitzen heute bis zu zwanzig bewegliche Gelenke und weiche Drucksensoren. Damit kann ein Roboter ein zerbrechliches Ei sicher halten, ohne die Schale einzudrücken.</a:t>
-            </a:r>
-            <a:endParaRPr lang="en-US" sz="1500" dirty="0"/>
           </a:p>
         </p:txBody>
       </p:sp>
@@ -7500,8 +7440,8 @@
         </p:nvSpPr>
         <p:spPr>
           <a:xfrm>
-            <a:off x="5257800" y="822960"/>
-            <a:ext cx="3429000" cy="2651760"/>
+            <a:off x="5486400" y="822960"/>
+            <a:ext cx="3200400" cy="2651760"/>
           </a:xfrm>
           <a:prstGeom prst="roundRect">
             <a:avLst>
@@ -7527,8 +7467,8 @@
         </p:nvSpPr>
         <p:spPr>
           <a:xfrm>
-            <a:off x="5257800" y="960120"/>
-            <a:ext cx="3429000" cy="822960"/>
+            <a:off x="5486400" y="960120"/>
+            <a:ext cx="3200400" cy="822960"/>
           </a:xfrm>
           <a:prstGeom prst="rect">
             <a:avLst/>
@@ -7566,8 +7506,8 @@
         </p:nvSpPr>
         <p:spPr>
           <a:xfrm>
-            <a:off x="5486400" y="1874520"/>
-            <a:ext cx="2971800" cy="1463040"/>
+            <a:off x="5715000" y="1874520"/>
+            <a:ext cx="2743200" cy="1463040"/>
           </a:xfrm>
           <a:prstGeom prst="rect">
             <a:avLst/>
@@ -7602,8 +7542,8 @@
         </p:nvSpPr>
         <p:spPr>
           <a:xfrm>
-            <a:off x="5257800" y="3566160"/>
-            <a:ext cx="3429000" cy="228600"/>
+            <a:off x="5486400" y="3566160"/>
+            <a:ext cx="3200400" cy="228600"/>
           </a:xfrm>
           <a:prstGeom prst="rect">
             <a:avLst/>
@@ -7699,8 +7639,8 @@
         </p:nvSpPr>
         <p:spPr>
           <a:xfrm>
-            <a:off x="457200" y="640080"/>
-            <a:ext cx="4160520" cy="1051560"/>
+            <a:off x="457200" y="594360"/>
+            <a:ext cx="4572000" cy="1143000"/>
           </a:xfrm>
           <a:prstGeom prst="rect">
             <a:avLst/>
@@ -7718,7 +7658,7 @@
               <a:buNone/>
             </a:pPr>
             <a:r>
-              <a:rPr lang="en-US" sz="2400" b="1" dirty="0">
+              <a:rPr lang="en-US" sz="2600" b="1" dirty="0">
                 <a:solidFill>
                   <a:schemeClr val="tx2"/>
                 </a:solidFill>
@@ -7728,48 +7668,43 @@
               </a:rPr>
               <a:t>Lernen im digitalen Zwilling</a:t>
             </a:r>
+            <a:endParaRPr lang="en-US" sz="2600" dirty="0"/>
+          </a:p>
+        </p:txBody>
+      </p:sp>
+      <p:sp>
+        <p:nvSpPr>
+          <p:cNvPr id="4" name="Text"/>
+          <p:cNvSpPr txBox="1"/>
+          <p:nvPr/>
+        </p:nvSpPr>
+        <p:spPr>
+          <a:xfrm>
+            <a:off x="457200" y="1828800"/>
+            <a:ext cx="4572000" cy="2834640"/>
+          </a:xfrm>
+          <a:prstGeom prst="rect">
+            <a:avLst/>
+          </a:prstGeom>
+          <a:noFill/>
+          <a:ln/>
+        </p:spPr>
+        <p:txBody>
+          <a:bodyPr wrap="square" lIns="0" tIns="0" rIns="0" bIns="0" rtlCol="0" anchor="t"/>
+          <a:lstStyle/>
+          <a:p>
+            <a:pPr indent="0" marL="0">
+              <a:buNone/>
+            </a:pPr>
+            <a:r>
+              <a:rPr lang="en-US" sz="2400" dirty="0">
+                <a:solidFill>
+                  <a:schemeClr val="tx1"/>
+                </a:solidFill>
+              </a:rPr>
+              <a:t>In Computersimulationen wie NVIDIA Isaac Sim trainieren Roboter Millionen Aufgaben im Zeitraffer. Was die KI virtuell gelernt hat, funktioniert anschließend sofort in der echten Welt.</a:t>
+            </a:r>
             <a:endParaRPr lang="en-US" sz="2400" dirty="0"/>
-          </a:p>
-        </p:txBody>
-      </p:sp>
-      <p:sp>
-        <p:nvSpPr>
-          <p:cNvPr id="4" name="Text"/>
-          <p:cNvSpPr txBox="1"/>
-          <p:nvPr/>
-        </p:nvSpPr>
-        <p:spPr>
-          <a:xfrm>
-            <a:off x="457200" y="1783080"/>
-            <a:ext cx="4160520" cy="2834640"/>
-          </a:xfrm>
-          <a:prstGeom prst="rect">
-            <a:avLst/>
-          </a:prstGeom>
-          <a:noFill/>
-          <a:ln/>
-        </p:spPr>
-        <p:txBody>
-          <a:bodyPr wrap="square" lIns="0" tIns="0" rIns="0" bIns="0" rtlCol="0" anchor="t">
-            <a:normAutofit/>
-          </a:bodyPr>
-          <a:lstStyle/>
-          <a:p>
-            <a:pPr indent="0" marL="0">
-              <a:spcAft>
-                <a:spcPts val="600"/>
-              </a:spcAft>
-              <a:buNone/>
-            </a:pPr>
-            <a:r>
-              <a:rPr lang="en-US" sz="1500" dirty="0">
-                <a:solidFill>
-                  <a:schemeClr val="tx1"/>
-                </a:solidFill>
-              </a:rPr>
-              <a:t>In Computersimulationen wie NVIDIA Isaac Sim trainieren Roboter Millionen Aufgaben im Zeitraffer. Was die KI virtuell gelernt hat, funktioniert anschließend sofort in der echten Welt.</a:t>
-            </a:r>
-            <a:endParaRPr lang="en-US" sz="1500" dirty="0"/>
           </a:p>
         </p:txBody>
       </p:sp>
@@ -7817,8 +7752,8 @@
         </p:nvSpPr>
         <p:spPr>
           <a:xfrm>
-            <a:off x="5257800" y="822960"/>
-            <a:ext cx="3429000" cy="2651760"/>
+            <a:off x="5486400" y="822960"/>
+            <a:ext cx="3200400" cy="2651760"/>
           </a:xfrm>
           <a:prstGeom prst="roundRect">
             <a:avLst>
@@ -7844,8 +7779,8 @@
         </p:nvSpPr>
         <p:spPr>
           <a:xfrm>
-            <a:off x="5257800" y="960120"/>
-            <a:ext cx="3429000" cy="822960"/>
+            <a:off x="5486400" y="960120"/>
+            <a:ext cx="3200400" cy="822960"/>
           </a:xfrm>
           <a:prstGeom prst="rect">
             <a:avLst/>
@@ -7883,8 +7818,8 @@
         </p:nvSpPr>
         <p:spPr>
           <a:xfrm>
-            <a:off x="5486400" y="1874520"/>
-            <a:ext cx="2971800" cy="1463040"/>
+            <a:off x="5715000" y="1874520"/>
+            <a:ext cx="2743200" cy="1463040"/>
           </a:xfrm>
           <a:prstGeom prst="rect">
             <a:avLst/>
@@ -7919,8 +7854,8 @@
         </p:nvSpPr>
         <p:spPr>
           <a:xfrm>
-            <a:off x="5257800" y="3566160"/>
-            <a:ext cx="3429000" cy="228600"/>
+            <a:off x="5486400" y="3566160"/>
+            <a:ext cx="3200400" cy="228600"/>
           </a:xfrm>
           <a:prstGeom prst="rect">
             <a:avLst/>
@@ -8016,8 +7951,8 @@
         </p:nvSpPr>
         <p:spPr>
           <a:xfrm>
-            <a:off x="457200" y="640080"/>
-            <a:ext cx="4160520" cy="1051560"/>
+            <a:off x="457200" y="594360"/>
+            <a:ext cx="4572000" cy="1143000"/>
           </a:xfrm>
           <a:prstGeom prst="rect">
             <a:avLst/>
@@ -8035,7 +7970,7 @@
               <a:buNone/>
             </a:pPr>
             <a:r>
-              <a:rPr lang="en-US" sz="2400" b="1" dirty="0">
+              <a:rPr lang="en-US" sz="2600" b="1" dirty="0">
                 <a:solidFill>
                   <a:schemeClr val="tx2"/>
                 </a:solidFill>
@@ -8045,7 +7980,7 @@
               </a:rPr>
               <a:t>Balance und nachgiebige Gelenke</a:t>
             </a:r>
-            <a:endParaRPr lang="en-US" sz="2400" dirty="0"/>
+            <a:endParaRPr lang="en-US" sz="2600" dirty="0"/>
           </a:p>
         </p:txBody>
       </p:sp>
@@ -8057,36 +7992,31 @@
         </p:nvSpPr>
         <p:spPr>
           <a:xfrm>
-            <a:off x="457200" y="1783080"/>
-            <a:ext cx="4160520" cy="2834640"/>
-          </a:xfrm>
-          <a:prstGeom prst="rect">
-            <a:avLst/>
-          </a:prstGeom>
-          <a:noFill/>
-          <a:ln/>
-        </p:spPr>
-        <p:txBody>
-          <a:bodyPr wrap="square" lIns="0" tIns="0" rIns="0" bIns="0" rtlCol="0" anchor="t">
-            <a:normAutofit/>
-          </a:bodyPr>
-          <a:lstStyle/>
-          <a:p>
-            <a:pPr indent="0" marL="0">
-              <a:spcAft>
-                <a:spcPts val="600"/>
-              </a:spcAft>
-              <a:buNone/>
-            </a:pPr>
-            <a:r>
-              <a:rPr lang="en-US" sz="1500" dirty="0">
+            <a:off x="457200" y="1828800"/>
+            <a:ext cx="4572000" cy="2834640"/>
+          </a:xfrm>
+          <a:prstGeom prst="rect">
+            <a:avLst/>
+          </a:prstGeom>
+          <a:noFill/>
+          <a:ln/>
+        </p:spPr>
+        <p:txBody>
+          <a:bodyPr wrap="square" lIns="0" tIns="0" rIns="0" bIns="0" rtlCol="0" anchor="t"/>
+          <a:lstStyle/>
+          <a:p>
+            <a:pPr indent="0" marL="0">
+              <a:buNone/>
+            </a:pPr>
+            <a:r>
+              <a:rPr lang="en-US" sz="2200" dirty="0">
                 <a:solidFill>
                   <a:schemeClr val="tx1"/>
                 </a:solidFill>
               </a:rPr>
               <a:t>Spezielle Kraftsensoren und schnelle Algorithmen lassen Roboter selbst bei Stößen oder auf glattem Eis das Gleichgewicht halten. Bei direktem Kontakt mit Menschen stoppen die Gelenke sofort nachgiebig, um Unfälle in Wohnungen zu vermeiden.</a:t>
             </a:r>
-            <a:endParaRPr lang="en-US" sz="1500" dirty="0"/>
+            <a:endParaRPr lang="en-US" sz="2200" dirty="0"/>
           </a:p>
         </p:txBody>
       </p:sp>
@@ -8134,8 +8064,8 @@
         </p:nvSpPr>
         <p:spPr>
           <a:xfrm>
-            <a:off x="5257800" y="822960"/>
-            <a:ext cx="3429000" cy="2651760"/>
+            <a:off x="5486400" y="822960"/>
+            <a:ext cx="3200400" cy="2651760"/>
           </a:xfrm>
           <a:prstGeom prst="roundRect">
             <a:avLst>
@@ -8161,8 +8091,8 @@
         </p:nvSpPr>
         <p:spPr>
           <a:xfrm>
-            <a:off x="5257800" y="960120"/>
-            <a:ext cx="3429000" cy="822960"/>
+            <a:off x="5486400" y="960120"/>
+            <a:ext cx="3200400" cy="822960"/>
           </a:xfrm>
           <a:prstGeom prst="rect">
             <a:avLst/>
@@ -8200,8 +8130,8 @@
         </p:nvSpPr>
         <p:spPr>
           <a:xfrm>
-            <a:off x="5486400" y="1874520"/>
-            <a:ext cx="2971800" cy="1463040"/>
+            <a:off x="5715000" y="1874520"/>
+            <a:ext cx="2743200" cy="1463040"/>
           </a:xfrm>
           <a:prstGeom prst="rect">
             <a:avLst/>
@@ -8236,8 +8166,8 @@
         </p:nvSpPr>
         <p:spPr>
           <a:xfrm>
-            <a:off x="5257800" y="3566160"/>
-            <a:ext cx="3429000" cy="228600"/>
+            <a:off x="5486400" y="3566160"/>
+            <a:ext cx="3200400" cy="228600"/>
           </a:xfrm>
           <a:prstGeom prst="rect">
             <a:avLst/>
@@ -8333,8 +8263,8 @@
         </p:nvSpPr>
         <p:spPr>
           <a:xfrm>
-            <a:off x="457200" y="640080"/>
-            <a:ext cx="4160520" cy="1051560"/>
+            <a:off x="457200" y="594360"/>
+            <a:ext cx="4572000" cy="1143000"/>
           </a:xfrm>
           <a:prstGeom prst="rect">
             <a:avLst/>
@@ -8352,7 +8282,7 @@
               <a:buNone/>
             </a:pPr>
             <a:r>
-              <a:rPr lang="en-US" sz="2400" b="1" dirty="0">
+              <a:rPr lang="en-US" sz="2600" b="1" dirty="0">
                 <a:solidFill>
                   <a:schemeClr val="tx2"/>
                 </a:solidFill>
@@ -8362,7 +8292,7 @@
               </a:rPr>
               <a:t>Kompakte Aktuatoren und Akkus</a:t>
             </a:r>
-            <a:endParaRPr lang="en-US" sz="2400" dirty="0"/>
+            <a:endParaRPr lang="en-US" sz="2600" dirty="0"/>
           </a:p>
         </p:txBody>
       </p:sp>
@@ -8374,36 +8304,31 @@
         </p:nvSpPr>
         <p:spPr>
           <a:xfrm>
-            <a:off x="457200" y="1783080"/>
-            <a:ext cx="4160520" cy="2834640"/>
-          </a:xfrm>
-          <a:prstGeom prst="rect">
-            <a:avLst/>
-          </a:prstGeom>
-          <a:noFill/>
-          <a:ln/>
-        </p:spPr>
-        <p:txBody>
-          <a:bodyPr wrap="square" lIns="0" tIns="0" rIns="0" bIns="0" rtlCol="0" anchor="t">
-            <a:normAutofit/>
-          </a:bodyPr>
-          <a:lstStyle/>
-          <a:p>
-            <a:pPr indent="0" marL="0">
-              <a:spcAft>
-                <a:spcPts val="600"/>
-              </a:spcAft>
-              <a:buNone/>
-            </a:pPr>
-            <a:r>
-              <a:rPr lang="en-US" sz="1500" dirty="0">
+            <a:off x="457200" y="1828800"/>
+            <a:ext cx="4572000" cy="2834640"/>
+          </a:xfrm>
+          <a:prstGeom prst="rect">
+            <a:avLst/>
+          </a:prstGeom>
+          <a:noFill/>
+          <a:ln/>
+        </p:spPr>
+        <p:txBody>
+          <a:bodyPr wrap="square" lIns="0" tIns="0" rIns="0" bIns="0" rtlCol="0" anchor="t"/>
+          <a:lstStyle/>
+          <a:p>
+            <a:pPr indent="0" marL="0">
+              <a:buNone/>
+            </a:pPr>
+            <a:r>
+              <a:rPr lang="en-US" sz="2200" dirty="0">
                 <a:solidFill>
                   <a:schemeClr val="tx1"/>
                 </a:solidFill>
               </a:rPr>
               <a:t>Anstelle von schweren Ölschläuchen nutzen moderne Roboter kompakte Elektromotoren und effiziente Festkörperakkus für mehrstündige Einsätze. Beim Abbremsen speisen diese Antriebe wie bei einem Elektroauto Energie zurück in den Speicher.</a:t>
             </a:r>
-            <a:endParaRPr lang="en-US" sz="1500" dirty="0"/>
+            <a:endParaRPr lang="en-US" sz="2200" dirty="0"/>
           </a:p>
         </p:txBody>
       </p:sp>
@@ -8451,8 +8376,8 @@
         </p:nvSpPr>
         <p:spPr>
           <a:xfrm>
-            <a:off x="5257800" y="822960"/>
-            <a:ext cx="3429000" cy="2651760"/>
+            <a:off x="5486400" y="822960"/>
+            <a:ext cx="3200400" cy="2651760"/>
           </a:xfrm>
           <a:prstGeom prst="roundRect">
             <a:avLst>
@@ -8478,8 +8403,8 @@
         </p:nvSpPr>
         <p:spPr>
           <a:xfrm>
-            <a:off x="5257800" y="960120"/>
-            <a:ext cx="3429000" cy="822960"/>
+            <a:off x="5486400" y="960120"/>
+            <a:ext cx="3200400" cy="822960"/>
           </a:xfrm>
           <a:prstGeom prst="rect">
             <a:avLst/>
@@ -8517,8 +8442,8 @@
         </p:nvSpPr>
         <p:spPr>
           <a:xfrm>
-            <a:off x="5486400" y="1874520"/>
-            <a:ext cx="2971800" cy="1463040"/>
+            <a:off x="5715000" y="1874520"/>
+            <a:ext cx="2743200" cy="1463040"/>
           </a:xfrm>
           <a:prstGeom prst="rect">
             <a:avLst/>
@@ -8553,8 +8478,8 @@
         </p:nvSpPr>
         <p:spPr>
           <a:xfrm>
-            <a:off x="5257800" y="3566160"/>
-            <a:ext cx="3429000" cy="228600"/>
+            <a:off x="5486400" y="3566160"/>
+            <a:ext cx="3200400" cy="228600"/>
           </a:xfrm>
           <a:prstGeom prst="rect">
             <a:avLst/>
@@ -8650,8 +8575,8 @@
         </p:nvSpPr>
         <p:spPr>
           <a:xfrm>
-            <a:off x="457200" y="640080"/>
-            <a:ext cx="4160520" cy="1051560"/>
+            <a:off x="457200" y="594360"/>
+            <a:ext cx="4572000" cy="1143000"/>
           </a:xfrm>
           <a:prstGeom prst="rect">
             <a:avLst/>
@@ -8669,7 +8594,7 @@
               <a:buNone/>
             </a:pPr>
             <a:r>
-              <a:rPr lang="en-US" sz="2400" b="1" dirty="0">
+              <a:rPr lang="en-US" sz="2600" b="1" dirty="0">
                 <a:solidFill>
                   <a:schemeClr val="tx2"/>
                 </a:solidFill>
@@ -8679,48 +8604,43 @@
               </a:rPr>
               <a:t>3D-Sehen mit LiDAR und Kameras</a:t>
             </a:r>
+            <a:endParaRPr lang="en-US" sz="2600" dirty="0"/>
+          </a:p>
+        </p:txBody>
+      </p:sp>
+      <p:sp>
+        <p:nvSpPr>
+          <p:cNvPr id="4" name="Text"/>
+          <p:cNvSpPr txBox="1"/>
+          <p:nvPr/>
+        </p:nvSpPr>
+        <p:spPr>
+          <a:xfrm>
+            <a:off x="457200" y="1828800"/>
+            <a:ext cx="4572000" cy="2834640"/>
+          </a:xfrm>
+          <a:prstGeom prst="rect">
+            <a:avLst/>
+          </a:prstGeom>
+          <a:noFill/>
+          <a:ln/>
+        </p:spPr>
+        <p:txBody>
+          <a:bodyPr wrap="square" lIns="0" tIns="0" rIns="0" bIns="0" rtlCol="0" anchor="t"/>
+          <a:lstStyle/>
+          <a:p>
+            <a:pPr indent="0" marL="0">
+              <a:buNone/>
+            </a:pPr>
+            <a:r>
+              <a:rPr lang="en-US" sz="2400" dirty="0">
+                <a:solidFill>
+                  <a:schemeClr val="tx1"/>
+                </a:solidFill>
+              </a:rPr>
+              <a:t>Durch die Kombination von Tiefenkameras und Laserscannern baut der Roboter eine Echtzeit-Karte auf. Er erkennt bewegte Hindernisse sofort und läuft sicher an Menschen und Haustieren vorbei.</a:t>
+            </a:r>
             <a:endParaRPr lang="en-US" sz="2400" dirty="0"/>
-          </a:p>
-        </p:txBody>
-      </p:sp>
-      <p:sp>
-        <p:nvSpPr>
-          <p:cNvPr id="4" name="Text"/>
-          <p:cNvSpPr txBox="1"/>
-          <p:nvPr/>
-        </p:nvSpPr>
-        <p:spPr>
-          <a:xfrm>
-            <a:off x="457200" y="1783080"/>
-            <a:ext cx="4160520" cy="2834640"/>
-          </a:xfrm>
-          <a:prstGeom prst="rect">
-            <a:avLst/>
-          </a:prstGeom>
-          <a:noFill/>
-          <a:ln/>
-        </p:spPr>
-        <p:txBody>
-          <a:bodyPr wrap="square" lIns="0" tIns="0" rIns="0" bIns="0" rtlCol="0" anchor="t">
-            <a:normAutofit/>
-          </a:bodyPr>
-          <a:lstStyle/>
-          <a:p>
-            <a:pPr indent="0" marL="0">
-              <a:spcAft>
-                <a:spcPts val="600"/>
-              </a:spcAft>
-              <a:buNone/>
-            </a:pPr>
-            <a:r>
-              <a:rPr lang="en-US" sz="1500" dirty="0">
-                <a:solidFill>
-                  <a:schemeClr val="tx1"/>
-                </a:solidFill>
-              </a:rPr>
-              <a:t>Durch die Kombination von Tiefenkameras und Laserscannern baut der Roboter eine Echtzeit-Karte auf. Er erkennt bewegte Hindernisse sofort und läuft sicher an Menschen und Haustieren vorbei.</a:t>
-            </a:r>
-            <a:endParaRPr lang="en-US" sz="1500" dirty="0"/>
           </a:p>
         </p:txBody>
       </p:sp>
@@ -8768,8 +8688,8 @@
         </p:nvSpPr>
         <p:spPr>
           <a:xfrm>
-            <a:off x="5257800" y="822960"/>
-            <a:ext cx="3429000" cy="2651760"/>
+            <a:off x="5486400" y="822960"/>
+            <a:ext cx="3200400" cy="2651760"/>
           </a:xfrm>
           <a:prstGeom prst="roundRect">
             <a:avLst>
@@ -8795,8 +8715,8 @@
         </p:nvSpPr>
         <p:spPr>
           <a:xfrm>
-            <a:off x="5257800" y="960120"/>
-            <a:ext cx="3429000" cy="822960"/>
+            <a:off x="5486400" y="960120"/>
+            <a:ext cx="3200400" cy="822960"/>
           </a:xfrm>
           <a:prstGeom prst="rect">
             <a:avLst/>
@@ -8834,8 +8754,8 @@
         </p:nvSpPr>
         <p:spPr>
           <a:xfrm>
-            <a:off x="5486400" y="1874520"/>
-            <a:ext cx="2971800" cy="1463040"/>
+            <a:off x="5715000" y="1874520"/>
+            <a:ext cx="2743200" cy="1463040"/>
           </a:xfrm>
           <a:prstGeom prst="rect">
             <a:avLst/>
@@ -8870,8 +8790,8 @@
         </p:nvSpPr>
         <p:spPr>
           <a:xfrm>
-            <a:off x="5257800" y="3566160"/>
-            <a:ext cx="3429000" cy="228600"/>
+            <a:off x="5486400" y="3566160"/>
+            <a:ext cx="3200400" cy="228600"/>
           </a:xfrm>
           <a:prstGeom prst="rect">
             <a:avLst/>
@@ -8967,8 +8887,8 @@
         </p:nvSpPr>
         <p:spPr>
           <a:xfrm>
-            <a:off x="457200" y="640080"/>
-            <a:ext cx="4160520" cy="1051560"/>
+            <a:off x="457200" y="594360"/>
+            <a:ext cx="4572000" cy="1143000"/>
           </a:xfrm>
           <a:prstGeom prst="rect">
             <a:avLst/>
@@ -8986,7 +8906,7 @@
               <a:buNone/>
             </a:pPr>
             <a:r>
-              <a:rPr lang="en-US" sz="2400" b="1" dirty="0">
+              <a:rPr lang="en-US" sz="2600" b="1" dirty="0">
                 <a:solidFill>
                   <a:schemeClr val="tx2"/>
                 </a:solidFill>
@@ -8996,7 +8916,7 @@
               </a:rPr>
               <a:t>1X NEO: Der Traum vom Roboter-Butler</a:t>
             </a:r>
-            <a:endParaRPr lang="en-US" sz="2400" dirty="0"/>
+            <a:endParaRPr lang="en-US" sz="2600" dirty="0"/>
           </a:p>
         </p:txBody>
       </p:sp>
@@ -9008,36 +8928,31 @@
         </p:nvSpPr>
         <p:spPr>
           <a:xfrm>
-            <a:off x="457200" y="1783080"/>
-            <a:ext cx="4160520" cy="2834640"/>
-          </a:xfrm>
-          <a:prstGeom prst="rect">
-            <a:avLst/>
-          </a:prstGeom>
-          <a:noFill/>
-          <a:ln/>
-        </p:spPr>
-        <p:txBody>
-          <a:bodyPr wrap="square" lIns="0" tIns="0" rIns="0" bIns="0" rtlCol="0" anchor="t">
-            <a:normAutofit/>
-          </a:bodyPr>
-          <a:lstStyle/>
-          <a:p>
-            <a:pPr indent="0" marL="0">
-              <a:spcAft>
-                <a:spcPts val="600"/>
-              </a:spcAft>
-              <a:buNone/>
-            </a:pPr>
-            <a:r>
-              <a:rPr lang="en-US" sz="1500" dirty="0">
+            <a:off x="457200" y="1828800"/>
+            <a:ext cx="4572000" cy="2834640"/>
+          </a:xfrm>
+          <a:prstGeom prst="rect">
+            <a:avLst/>
+          </a:prstGeom>
+          <a:noFill/>
+          <a:ln/>
+        </p:spPr>
+        <p:txBody>
+          <a:bodyPr wrap="square" lIns="0" tIns="0" rIns="0" bIns="0" rtlCol="0" anchor="t"/>
+          <a:lstStyle/>
+          <a:p>
+            <a:pPr indent="0" marL="0">
+              <a:buNone/>
+            </a:pPr>
+            <a:r>
+              <a:rPr lang="en-US" sz="2200" dirty="0">
                 <a:solidFill>
                   <a:schemeClr val="tx1"/>
                 </a:solidFill>
               </a:rPr>
               <a:t>Technologieunternehmen wie 1X entwickeln leise, textilgekleidete Roboter, die den Menschen im privaten Wohnbereich sicher unterstützen. Sie sollen als Roboter-Butler den Alltag spürbar erleichtern und bei schweren Routinetätigkeiten helfen.</a:t>
             </a:r>
-            <a:endParaRPr lang="en-US" sz="1500" dirty="0"/>
+            <a:endParaRPr lang="en-US" sz="2200" dirty="0"/>
           </a:p>
         </p:txBody>
       </p:sp>
@@ -9095,8 +9010,8 @@
         </p:blipFill>
         <p:spPr>
           <a:xfrm>
-            <a:off x="5257800" y="822960"/>
-            <a:ext cx="3429000" cy="1928813"/>
+            <a:off x="5486400" y="822960"/>
+            <a:ext cx="3200400" cy="1800225"/>
           </a:xfrm>
           <a:prstGeom prst="rect">
             <a:avLst/>
@@ -9113,7 +9028,7 @@
         </p:nvSpPr>
         <p:spPr>
           <a:xfrm>
-            <a:off x="6652260" y="1467326"/>
+            <a:off x="6766560" y="1403032"/>
             <a:ext cx="640080" cy="640080"/>
           </a:xfrm>
           <a:prstGeom prst="ellipse">
@@ -9142,7 +9057,7 @@
         </p:nvSpPr>
         <p:spPr>
           <a:xfrm rot="5400000">
-            <a:off x="6880860" y="1641062"/>
+            <a:off x="6995160" y="1576769"/>
             <a:ext cx="256032" cy="292608"/>
           </a:xfrm>
           <a:prstGeom prst="triangle">
@@ -9167,8 +9082,8 @@
         </p:nvSpPr>
         <p:spPr>
           <a:xfrm>
-            <a:off x="5257800" y="2843213"/>
-            <a:ext cx="3429000" cy="548640"/>
+            <a:off x="5486400" y="2714625"/>
+            <a:ext cx="3200400" cy="548640"/>
           </a:xfrm>
           <a:prstGeom prst="rect">
             <a:avLst/>
@@ -9203,8 +9118,8 @@
         </p:nvSpPr>
         <p:spPr>
           <a:xfrm>
-            <a:off x="5257800" y="3566160"/>
-            <a:ext cx="3429000" cy="502920"/>
+            <a:off x="5486400" y="3566160"/>
+            <a:ext cx="3200400" cy="502920"/>
           </a:xfrm>
           <a:prstGeom prst="rect">
             <a:avLst/>
@@ -9321,8 +9236,8 @@
         </p:nvSpPr>
         <p:spPr>
           <a:xfrm>
-            <a:off x="457200" y="640080"/>
-            <a:ext cx="4160520" cy="1051560"/>
+            <a:off x="457200" y="594360"/>
+            <a:ext cx="4572000" cy="1143000"/>
           </a:xfrm>
           <a:prstGeom prst="rect">
             <a:avLst/>
@@ -9340,7 +9255,7 @@
               <a:buNone/>
             </a:pPr>
             <a:r>
-              <a:rPr lang="en-US" sz="2400" b="1" dirty="0">
+              <a:rPr lang="en-US" sz="2600" b="1" dirty="0">
                 <a:solidFill>
                   <a:schemeClr val="tx2"/>
                 </a:solidFill>
@@ -9350,7 +9265,7 @@
               </a:rPr>
               <a:t>Hausarbeiten und erschwingliche Modelle</a:t>
             </a:r>
-            <a:endParaRPr lang="en-US" sz="2400" dirty="0"/>
+            <a:endParaRPr lang="en-US" sz="2600" dirty="0"/>
           </a:p>
         </p:txBody>
       </p:sp>
@@ -9362,36 +9277,31 @@
         </p:nvSpPr>
         <p:spPr>
           <a:xfrm>
-            <a:off x="457200" y="1783080"/>
-            <a:ext cx="4160520" cy="2834640"/>
-          </a:xfrm>
-          <a:prstGeom prst="rect">
-            <a:avLst/>
-          </a:prstGeom>
-          <a:noFill/>
-          <a:ln/>
-        </p:spPr>
-        <p:txBody>
-          <a:bodyPr wrap="square" lIns="0" tIns="0" rIns="0" bIns="0" rtlCol="0" anchor="t">
-            <a:normAutofit/>
-          </a:bodyPr>
-          <a:lstStyle/>
-          <a:p>
-            <a:pPr indent="0" marL="0">
-              <a:spcAft>
-                <a:spcPts val="600"/>
-              </a:spcAft>
-              <a:buNone/>
-            </a:pPr>
-            <a:r>
-              <a:rPr lang="en-US" sz="1500" dirty="0">
+            <a:off x="457200" y="1828800"/>
+            <a:ext cx="4572000" cy="2834640"/>
+          </a:xfrm>
+          <a:prstGeom prst="rect">
+            <a:avLst/>
+          </a:prstGeom>
+          <a:noFill/>
+          <a:ln/>
+        </p:spPr>
+        <p:txBody>
+          <a:bodyPr wrap="square" lIns="0" tIns="0" rIns="0" bIns="0" rtlCol="0" anchor="t"/>
+          <a:lstStyle/>
+          <a:p>
+            <a:pPr indent="0" marL="0">
+              <a:buNone/>
+            </a:pPr>
+            <a:r>
+              <a:rPr lang="en-US" sz="2200" dirty="0">
                 <a:solidFill>
                   <a:schemeClr val="tx1"/>
                 </a:solidFill>
               </a:rPr>
               <a:t>Durch maschinelles Lernen meistern Roboter wie der günstige Unitree G1 alltägliche Aufgaben wie das Zusammenfalten von Wäsche. Sinkende Preise unter 16.000 Dollar machen diese Helfer zunehmend auch für Privathaushalte und Entwickler bezahlbar.</a:t>
             </a:r>
-            <a:endParaRPr lang="en-US" sz="1500" dirty="0"/>
+            <a:endParaRPr lang="en-US" sz="2200" dirty="0"/>
           </a:p>
         </p:txBody>
       </p:sp>
@@ -9439,8 +9349,8 @@
         </p:nvSpPr>
         <p:spPr>
           <a:xfrm>
-            <a:off x="5257800" y="822960"/>
-            <a:ext cx="3429000" cy="2651760"/>
+            <a:off x="5486400" y="822960"/>
+            <a:ext cx="3200400" cy="2651760"/>
           </a:xfrm>
           <a:prstGeom prst="roundRect">
             <a:avLst>
@@ -9466,8 +9376,8 @@
         </p:nvSpPr>
         <p:spPr>
           <a:xfrm>
-            <a:off x="5257800" y="960120"/>
-            <a:ext cx="3429000" cy="822960"/>
+            <a:off x="5486400" y="960120"/>
+            <a:ext cx="3200400" cy="822960"/>
           </a:xfrm>
           <a:prstGeom prst="rect">
             <a:avLst/>
@@ -9505,8 +9415,8 @@
         </p:nvSpPr>
         <p:spPr>
           <a:xfrm>
-            <a:off x="5486400" y="1874520"/>
-            <a:ext cx="2971800" cy="1463040"/>
+            <a:off x="5715000" y="1874520"/>
+            <a:ext cx="2743200" cy="1463040"/>
           </a:xfrm>
           <a:prstGeom prst="rect">
             <a:avLst/>
@@ -9541,8 +9451,8 @@
         </p:nvSpPr>
         <p:spPr>
           <a:xfrm>
-            <a:off x="5257800" y="3566160"/>
-            <a:ext cx="3429000" cy="228600"/>
+            <a:off x="5486400" y="3566160"/>
+            <a:ext cx="3200400" cy="228600"/>
           </a:xfrm>
           <a:prstGeom prst="rect">
             <a:avLst/>
@@ -9638,8 +9548,8 @@
         </p:nvSpPr>
         <p:spPr>
           <a:xfrm>
-            <a:off x="457200" y="640080"/>
-            <a:ext cx="4160520" cy="1051560"/>
+            <a:off x="457200" y="594360"/>
+            <a:ext cx="4572000" cy="1143000"/>
           </a:xfrm>
           <a:prstGeom prst="rect">
             <a:avLst/>
@@ -9657,7 +9567,7 @@
               <a:buNone/>
             </a:pPr>
             <a:r>
-              <a:rPr lang="en-US" sz="2400" b="1" dirty="0">
+              <a:rPr lang="en-US" sz="2600" b="1" dirty="0">
                 <a:solidFill>
                   <a:schemeClr val="tx2"/>
                 </a:solidFill>
@@ -9667,48 +9577,43 @@
               </a:rPr>
               <a:t>Unterstützung für Senioren und Pflege</a:t>
             </a:r>
+            <a:endParaRPr lang="en-US" sz="2600" dirty="0"/>
+          </a:p>
+        </p:txBody>
+      </p:sp>
+      <p:sp>
+        <p:nvSpPr>
+          <p:cNvPr id="4" name="Text"/>
+          <p:cNvSpPr txBox="1"/>
+          <p:nvPr/>
+        </p:nvSpPr>
+        <p:spPr>
+          <a:xfrm>
+            <a:off x="457200" y="1828800"/>
+            <a:ext cx="4572000" cy="2834640"/>
+          </a:xfrm>
+          <a:prstGeom prst="rect">
+            <a:avLst/>
+          </a:prstGeom>
+          <a:noFill/>
+          <a:ln/>
+        </p:spPr>
+        <p:txBody>
+          <a:bodyPr wrap="square" lIns="0" tIns="0" rIns="0" bIns="0" rtlCol="0" anchor="t"/>
+          <a:lstStyle/>
+          <a:p>
+            <a:pPr indent="0" marL="0">
+              <a:buNone/>
+            </a:pPr>
+            <a:r>
+              <a:rPr lang="en-US" sz="2400" dirty="0">
+                <a:solidFill>
+                  <a:schemeClr val="tx1"/>
+                </a:solidFill>
+              </a:rPr>
+              <a:t>In alternden Gesellschaften können Roboter älteren Menschen beim Aufstehen und Gehen helfen. Sie erinnern verlässlich an wichtige Medikamente und rufen im Notfall sofort ärztliche Hilfe.</a:t>
+            </a:r>
             <a:endParaRPr lang="en-US" sz="2400" dirty="0"/>
-          </a:p>
-        </p:txBody>
-      </p:sp>
-      <p:sp>
-        <p:nvSpPr>
-          <p:cNvPr id="4" name="Text"/>
-          <p:cNvSpPr txBox="1"/>
-          <p:nvPr/>
-        </p:nvSpPr>
-        <p:spPr>
-          <a:xfrm>
-            <a:off x="457200" y="1783080"/>
-            <a:ext cx="4160520" cy="2834640"/>
-          </a:xfrm>
-          <a:prstGeom prst="rect">
-            <a:avLst/>
-          </a:prstGeom>
-          <a:noFill/>
-          <a:ln/>
-        </p:spPr>
-        <p:txBody>
-          <a:bodyPr wrap="square" lIns="0" tIns="0" rIns="0" bIns="0" rtlCol="0" anchor="t">
-            <a:normAutofit/>
-          </a:bodyPr>
-          <a:lstStyle/>
-          <a:p>
-            <a:pPr indent="0" marL="0">
-              <a:spcAft>
-                <a:spcPts val="600"/>
-              </a:spcAft>
-              <a:buNone/>
-            </a:pPr>
-            <a:r>
-              <a:rPr lang="en-US" sz="1500" dirty="0">
-                <a:solidFill>
-                  <a:schemeClr val="tx1"/>
-                </a:solidFill>
-              </a:rPr>
-              <a:t>In alternden Gesellschaften können Roboter älteren Menschen beim Aufstehen und Gehen helfen. Sie erinnern verlässlich an wichtige Medikamente und rufen im Notfall sofort ärztliche Hilfe.</a:t>
-            </a:r>
-            <a:endParaRPr lang="en-US" sz="1500" dirty="0"/>
           </a:p>
         </p:txBody>
       </p:sp>
@@ -9756,8 +9661,8 @@
         </p:nvSpPr>
         <p:spPr>
           <a:xfrm>
-            <a:off x="5257800" y="822960"/>
-            <a:ext cx="3429000" cy="2651760"/>
+            <a:off x="5486400" y="822960"/>
+            <a:ext cx="3200400" cy="2651760"/>
           </a:xfrm>
           <a:prstGeom prst="roundRect">
             <a:avLst>
@@ -9783,8 +9688,8 @@
         </p:nvSpPr>
         <p:spPr>
           <a:xfrm>
-            <a:off x="5257800" y="960120"/>
-            <a:ext cx="3429000" cy="822960"/>
+            <a:off x="5486400" y="960120"/>
+            <a:ext cx="3200400" cy="822960"/>
           </a:xfrm>
           <a:prstGeom prst="rect">
             <a:avLst/>
@@ -9822,8 +9727,8 @@
         </p:nvSpPr>
         <p:spPr>
           <a:xfrm>
-            <a:off x="5486400" y="1874520"/>
-            <a:ext cx="2971800" cy="1463040"/>
+            <a:off x="5715000" y="1874520"/>
+            <a:ext cx="2743200" cy="1463040"/>
           </a:xfrm>
           <a:prstGeom prst="rect">
             <a:avLst/>
@@ -9858,8 +9763,8 @@
         </p:nvSpPr>
         <p:spPr>
           <a:xfrm>
-            <a:off x="5257800" y="3566160"/>
-            <a:ext cx="3429000" cy="228600"/>
+            <a:off x="5486400" y="3566160"/>
+            <a:ext cx="3200400" cy="228600"/>
           </a:xfrm>
           <a:prstGeom prst="rect">
             <a:avLst/>
@@ -9955,8 +9860,8 @@
         </p:nvSpPr>
         <p:spPr>
           <a:xfrm>
-            <a:off x="457200" y="640080"/>
-            <a:ext cx="4160520" cy="1051560"/>
+            <a:off x="457200" y="594360"/>
+            <a:ext cx="4572000" cy="1143000"/>
           </a:xfrm>
           <a:prstGeom prst="rect">
             <a:avLst/>
@@ -9974,7 +9879,7 @@
               <a:buNone/>
             </a:pPr>
             <a:r>
-              <a:rPr lang="en-US" sz="2400" b="1" dirty="0">
+              <a:rPr lang="en-US" sz="2600" b="1" dirty="0">
                 <a:solidFill>
                   <a:schemeClr val="tx2"/>
                 </a:solidFill>
@@ -9984,7 +9889,7 @@
               </a:rPr>
               <a:t>Marktprognosen und Mietmodelle (RaaS)</a:t>
             </a:r>
-            <a:endParaRPr lang="en-US" sz="2400" dirty="0"/>
+            <a:endParaRPr lang="en-US" sz="2600" dirty="0"/>
           </a:p>
         </p:txBody>
       </p:sp>
@@ -9996,36 +9901,31 @@
         </p:nvSpPr>
         <p:spPr>
           <a:xfrm>
-            <a:off x="457200" y="1783080"/>
-            <a:ext cx="4160520" cy="2834640"/>
-          </a:xfrm>
-          <a:prstGeom prst="rect">
-            <a:avLst/>
-          </a:prstGeom>
-          <a:noFill/>
-          <a:ln/>
-        </p:spPr>
-        <p:txBody>
-          <a:bodyPr wrap="square" lIns="0" tIns="0" rIns="0" bIns="0" rtlCol="0" anchor="t">
-            <a:normAutofit/>
-          </a:bodyPr>
-          <a:lstStyle/>
-          <a:p>
-            <a:pPr indent="0" marL="0">
-              <a:spcAft>
-                <a:spcPts val="600"/>
-              </a:spcAft>
-              <a:buNone/>
-            </a:pPr>
-            <a:r>
-              <a:rPr lang="en-US" sz="1500" dirty="0">
+            <a:off x="457200" y="1828800"/>
+            <a:ext cx="4572000" cy="2834640"/>
+          </a:xfrm>
+          <a:prstGeom prst="rect">
+            <a:avLst/>
+          </a:prstGeom>
+          <a:noFill/>
+          <a:ln/>
+        </p:spPr>
+        <p:txBody>
+          <a:bodyPr wrap="square" lIns="0" tIns="0" rIns="0" bIns="0" rtlCol="0" anchor="t"/>
+          <a:lstStyle/>
+          <a:p>
+            <a:pPr indent="0" marL="0">
+              <a:buNone/>
+            </a:pPr>
+            <a:r>
+              <a:rPr lang="en-US" sz="2200" dirty="0">
                 <a:solidFill>
                   <a:schemeClr val="tx1"/>
                 </a:solidFill>
               </a:rPr>
               <a:t>Bis 2030 könnten über 500.000 humanoide Roboter im Einsatz sein, von denen viele monatlich gemietet statt gekauft werden. Der Hersteller kümmert sich bei diesem Dienstleistungsmodell um alle Software-Updates und Reparaturen.</a:t>
             </a:r>
-            <a:endParaRPr lang="en-US" sz="1500" dirty="0"/>
+            <a:endParaRPr lang="en-US" sz="2200" dirty="0"/>
           </a:p>
         </p:txBody>
       </p:sp>
@@ -10073,8 +9973,8 @@
         </p:nvSpPr>
         <p:spPr>
           <a:xfrm>
-            <a:off x="5257800" y="822960"/>
-            <a:ext cx="3429000" cy="2651760"/>
+            <a:off x="5486400" y="822960"/>
+            <a:ext cx="3200400" cy="2651760"/>
           </a:xfrm>
           <a:prstGeom prst="roundRect">
             <a:avLst>
@@ -10100,8 +10000,8 @@
         </p:nvSpPr>
         <p:spPr>
           <a:xfrm>
-            <a:off x="5257800" y="960120"/>
-            <a:ext cx="3429000" cy="822960"/>
+            <a:off x="5486400" y="960120"/>
+            <a:ext cx="3200400" cy="822960"/>
           </a:xfrm>
           <a:prstGeom prst="rect">
             <a:avLst/>
@@ -10139,8 +10039,8 @@
         </p:nvSpPr>
         <p:spPr>
           <a:xfrm>
-            <a:off x="5486400" y="1874520"/>
-            <a:ext cx="2971800" cy="1463040"/>
+            <a:off x="5715000" y="1874520"/>
+            <a:ext cx="2743200" cy="1463040"/>
           </a:xfrm>
           <a:prstGeom prst="rect">
             <a:avLst/>
@@ -10175,8 +10075,8 @@
         </p:nvSpPr>
         <p:spPr>
           <a:xfrm>
-            <a:off x="5257800" y="3566160"/>
-            <a:ext cx="3429000" cy="228600"/>
+            <a:off x="5486400" y="3566160"/>
+            <a:ext cx="3200400" cy="228600"/>
           </a:xfrm>
           <a:prstGeom prst="rect">
             <a:avLst/>
@@ -10272,8 +10172,8 @@
         </p:nvSpPr>
         <p:spPr>
           <a:xfrm>
-            <a:off x="457200" y="640080"/>
-            <a:ext cx="4160520" cy="1051560"/>
+            <a:off x="457200" y="594360"/>
+            <a:ext cx="4572000" cy="1143000"/>
           </a:xfrm>
           <a:prstGeom prst="rect">
             <a:avLst/>
@@ -10291,7 +10191,7 @@
               <a:buNone/>
             </a:pPr>
             <a:r>
-              <a:rPr lang="en-US" sz="2400" b="1" dirty="0">
+              <a:rPr lang="en-US" sz="2600" b="1" dirty="0">
                 <a:solidFill>
                   <a:schemeClr val="tx2"/>
                 </a:solidFill>
@@ -10301,48 +10201,43 @@
               </a:rPr>
               <a:t>Datenschutz und ethische Regeln</a:t>
             </a:r>
+            <a:endParaRPr lang="en-US" sz="2600" dirty="0"/>
+          </a:p>
+        </p:txBody>
+      </p:sp>
+      <p:sp>
+        <p:nvSpPr>
+          <p:cNvPr id="4" name="Text"/>
+          <p:cNvSpPr txBox="1"/>
+          <p:nvPr/>
+        </p:nvSpPr>
+        <p:spPr>
+          <a:xfrm>
+            <a:off x="457200" y="1828800"/>
+            <a:ext cx="4572000" cy="2834640"/>
+          </a:xfrm>
+          <a:prstGeom prst="rect">
+            <a:avLst/>
+          </a:prstGeom>
+          <a:noFill/>
+          <a:ln/>
+        </p:spPr>
+        <p:txBody>
+          <a:bodyPr wrap="square" lIns="0" tIns="0" rIns="0" bIns="0" rtlCol="0" anchor="t"/>
+          <a:lstStyle/>
+          <a:p>
+            <a:pPr indent="0" marL="0">
+              <a:buNone/>
+            </a:pPr>
+            <a:r>
+              <a:rPr lang="en-US" sz="2400" dirty="0">
+                <a:solidFill>
+                  <a:schemeClr val="tx1"/>
+                </a:solidFill>
+              </a:rPr>
+              <a:t>Da Haushaltsroboter Kameras und Mikrofone besitzen, müssen persönliche Daten streng geschützt werden. Internationale Richtlinien stellen sicher, dass alle Aufnahmen privat auf dem Gerät bleiben.</a:t>
+            </a:r>
             <a:endParaRPr lang="en-US" sz="2400" dirty="0"/>
-          </a:p>
-        </p:txBody>
-      </p:sp>
-      <p:sp>
-        <p:nvSpPr>
-          <p:cNvPr id="4" name="Text"/>
-          <p:cNvSpPr txBox="1"/>
-          <p:nvPr/>
-        </p:nvSpPr>
-        <p:spPr>
-          <a:xfrm>
-            <a:off x="457200" y="1783080"/>
-            <a:ext cx="4160520" cy="2834640"/>
-          </a:xfrm>
-          <a:prstGeom prst="rect">
-            <a:avLst/>
-          </a:prstGeom>
-          <a:noFill/>
-          <a:ln/>
-        </p:spPr>
-        <p:txBody>
-          <a:bodyPr wrap="square" lIns="0" tIns="0" rIns="0" bIns="0" rtlCol="0" anchor="t">
-            <a:normAutofit/>
-          </a:bodyPr>
-          <a:lstStyle/>
-          <a:p>
-            <a:pPr indent="0" marL="0">
-              <a:spcAft>
-                <a:spcPts val="600"/>
-              </a:spcAft>
-              <a:buNone/>
-            </a:pPr>
-            <a:r>
-              <a:rPr lang="en-US" sz="1500" dirty="0">
-                <a:solidFill>
-                  <a:schemeClr val="tx1"/>
-                </a:solidFill>
-              </a:rPr>
-              <a:t>Da Haushaltsroboter Kameras und Mikrofone besitzen, müssen persönliche Daten streng geschützt werden. Internationale Richtlinien stellen sicher, dass alle Aufnahmen privat auf dem Gerät bleiben.</a:t>
-            </a:r>
-            <a:endParaRPr lang="en-US" sz="1500" dirty="0"/>
           </a:p>
         </p:txBody>
       </p:sp>
@@ -10390,8 +10285,8 @@
         </p:nvSpPr>
         <p:spPr>
           <a:xfrm>
-            <a:off x="5257800" y="822960"/>
-            <a:ext cx="3429000" cy="2651760"/>
+            <a:off x="5486400" y="822960"/>
+            <a:ext cx="3200400" cy="2651760"/>
           </a:xfrm>
           <a:prstGeom prst="roundRect">
             <a:avLst>
@@ -10417,8 +10312,8 @@
         </p:nvSpPr>
         <p:spPr>
           <a:xfrm>
-            <a:off x="5257800" y="960120"/>
-            <a:ext cx="3429000" cy="822960"/>
+            <a:off x="5486400" y="960120"/>
+            <a:ext cx="3200400" cy="822960"/>
           </a:xfrm>
           <a:prstGeom prst="rect">
             <a:avLst/>
@@ -10456,8 +10351,8 @@
         </p:nvSpPr>
         <p:spPr>
           <a:xfrm>
-            <a:off x="5486400" y="1874520"/>
-            <a:ext cx="2971800" cy="1463040"/>
+            <a:off x="5715000" y="1874520"/>
+            <a:ext cx="2743200" cy="1463040"/>
           </a:xfrm>
           <a:prstGeom prst="rect">
             <a:avLst/>
@@ -10492,8 +10387,8 @@
         </p:nvSpPr>
         <p:spPr>
           <a:xfrm>
-            <a:off x="5257800" y="3566160"/>
-            <a:ext cx="3429000" cy="228600"/>
+            <a:off x="5486400" y="3566160"/>
+            <a:ext cx="3200400" cy="228600"/>
           </a:xfrm>
           <a:prstGeom prst="rect">
             <a:avLst/>
@@ -10589,8 +10484,8 @@
         </p:nvSpPr>
         <p:spPr>
           <a:xfrm>
-            <a:off x="457200" y="640080"/>
-            <a:ext cx="4160520" cy="1051560"/>
+            <a:off x="457200" y="594360"/>
+            <a:ext cx="4572000" cy="1143000"/>
           </a:xfrm>
           <a:prstGeom prst="rect">
             <a:avLst/>
@@ -10608,7 +10503,7 @@
               <a:buNone/>
             </a:pPr>
             <a:r>
-              <a:rPr lang="en-US" sz="2400" b="1" dirty="0">
+              <a:rPr lang="en-US" sz="2600" b="1" dirty="0">
                 <a:solidFill>
                   <a:schemeClr val="tx2"/>
                 </a:solidFill>
@@ -10618,48 +10513,43 @@
               </a:rPr>
               <a:t>Leonardos Roboter-Ritter (1495)</a:t>
             </a:r>
+            <a:endParaRPr lang="en-US" sz="2600" dirty="0"/>
+          </a:p>
+        </p:txBody>
+      </p:sp>
+      <p:sp>
+        <p:nvSpPr>
+          <p:cNvPr id="4" name="Text"/>
+          <p:cNvSpPr txBox="1"/>
+          <p:nvPr/>
+        </p:nvSpPr>
+        <p:spPr>
+          <a:xfrm>
+            <a:off x="457200" y="1828800"/>
+            <a:ext cx="4572000" cy="2834640"/>
+          </a:xfrm>
+          <a:prstGeom prst="rect">
+            <a:avLst/>
+          </a:prstGeom>
+          <a:noFill/>
+          <a:ln/>
+        </p:spPr>
+        <p:txBody>
+          <a:bodyPr wrap="square" lIns="0" tIns="0" rIns="0" bIns="0" rtlCol="0" anchor="t"/>
+          <a:lstStyle/>
+          <a:p>
+            <a:pPr indent="0" marL="0">
+              <a:buNone/>
+            </a:pPr>
+            <a:r>
+              <a:rPr lang="en-US" sz="2400" dirty="0">
+                <a:solidFill>
+                  <a:schemeClr val="tx1"/>
+                </a:solidFill>
+              </a:rPr>
+              <a:t>Schon im 15. Jahrhundert entwarf Leonardo da Vinci einen mechanischen Ritter mit Seilzügen und Rollen. Diese historische Zeichnung gilt heute als der erste Entwurf eines humanoiden Roboters.</a:t>
+            </a:r>
             <a:endParaRPr lang="en-US" sz="2400" dirty="0"/>
-          </a:p>
-        </p:txBody>
-      </p:sp>
-      <p:sp>
-        <p:nvSpPr>
-          <p:cNvPr id="4" name="Text"/>
-          <p:cNvSpPr txBox="1"/>
-          <p:nvPr/>
-        </p:nvSpPr>
-        <p:spPr>
-          <a:xfrm>
-            <a:off x="457200" y="1783080"/>
-            <a:ext cx="4160520" cy="2834640"/>
-          </a:xfrm>
-          <a:prstGeom prst="rect">
-            <a:avLst/>
-          </a:prstGeom>
-          <a:noFill/>
-          <a:ln/>
-        </p:spPr>
-        <p:txBody>
-          <a:bodyPr wrap="square" lIns="0" tIns="0" rIns="0" bIns="0" rtlCol="0" anchor="t">
-            <a:normAutofit/>
-          </a:bodyPr>
-          <a:lstStyle/>
-          <a:p>
-            <a:pPr indent="0" marL="0">
-              <a:spcAft>
-                <a:spcPts val="600"/>
-              </a:spcAft>
-              <a:buNone/>
-            </a:pPr>
-            <a:r>
-              <a:rPr lang="en-US" sz="1500" dirty="0">
-                <a:solidFill>
-                  <a:schemeClr val="tx1"/>
-                </a:solidFill>
-              </a:rPr>
-              <a:t>Schon im 15. Jahrhundert entwarf Leonardo da Vinci einen mechanischen Ritter mit Seilzügen und Rollen. Diese historische Zeichnung gilt heute als der erste Entwurf eines humanoiden Roboters.</a:t>
-            </a:r>
-            <a:endParaRPr lang="en-US" sz="1500" dirty="0"/>
           </a:p>
         </p:txBody>
       </p:sp>
@@ -10715,8 +10605,8 @@
         </p:blipFill>
         <p:spPr>
           <a:xfrm>
-            <a:off x="5257800" y="457200"/>
-            <a:ext cx="3429000" cy="3611880"/>
+            <a:off x="5486400" y="457200"/>
+            <a:ext cx="3200400" cy="3374136"/>
           </a:xfrm>
           <a:prstGeom prst="rect">
             <a:avLst/>
@@ -10731,8 +10621,8 @@
         </p:nvSpPr>
         <p:spPr>
           <a:xfrm>
-            <a:off x="5257800" y="4114800"/>
-            <a:ext cx="3429000" cy="201168"/>
+            <a:off x="5486400" y="3886200"/>
+            <a:ext cx="3200400" cy="201168"/>
           </a:xfrm>
           <a:prstGeom prst="rect">
             <a:avLst/>
@@ -10828,8 +10718,8 @@
         </p:nvSpPr>
         <p:spPr>
           <a:xfrm>
-            <a:off x="457200" y="640080"/>
-            <a:ext cx="4160520" cy="1051560"/>
+            <a:off x="457200" y="594360"/>
+            <a:ext cx="4572000" cy="1143000"/>
           </a:xfrm>
           <a:prstGeom prst="rect">
             <a:avLst/>
@@ -10847,7 +10737,7 @@
               <a:buNone/>
             </a:pPr>
             <a:r>
-              <a:rPr lang="en-US" sz="2400" b="1" dirty="0">
+              <a:rPr lang="en-US" sz="2600" b="1" dirty="0">
                 <a:solidFill>
                   <a:schemeClr val="tx2"/>
                 </a:solidFill>
@@ -10857,48 +10747,43 @@
               </a:rPr>
               <a:t>Aktuelle Hürden: Akkulaufzeit und Preis</a:t>
             </a:r>
+            <a:endParaRPr lang="en-US" sz="2600" dirty="0"/>
+          </a:p>
+        </p:txBody>
+      </p:sp>
+      <p:sp>
+        <p:nvSpPr>
+          <p:cNvPr id="4" name="Text"/>
+          <p:cNvSpPr txBox="1"/>
+          <p:nvPr/>
+        </p:nvSpPr>
+        <p:spPr>
+          <a:xfrm>
+            <a:off x="457200" y="1828800"/>
+            <a:ext cx="4572000" cy="2834640"/>
+          </a:xfrm>
+          <a:prstGeom prst="rect">
+            <a:avLst/>
+          </a:prstGeom>
+          <a:noFill/>
+          <a:ln/>
+        </p:spPr>
+        <p:txBody>
+          <a:bodyPr wrap="square" lIns="0" tIns="0" rIns="0" bIns="0" rtlCol="0" anchor="t"/>
+          <a:lstStyle/>
+          <a:p>
+            <a:pPr indent="0" marL="0">
+              <a:buNone/>
+            </a:pPr>
+            <a:r>
+              <a:rPr lang="en-US" sz="2400" dirty="0">
+                <a:solidFill>
+                  <a:schemeClr val="tx1"/>
+                </a:solidFill>
+              </a:rPr>
+              <a:t>Vor dem endgültigen Massendurchbruch müssen die Produktionskosten weiter fallen und die Akkulaufzeit steigen. Experten sind zuversichtlich, dass diese Herausforderungen schon bald gelöst werden.</a:t>
+            </a:r>
             <a:endParaRPr lang="en-US" sz="2400" dirty="0"/>
-          </a:p>
-        </p:txBody>
-      </p:sp>
-      <p:sp>
-        <p:nvSpPr>
-          <p:cNvPr id="4" name="Text"/>
-          <p:cNvSpPr txBox="1"/>
-          <p:nvPr/>
-        </p:nvSpPr>
-        <p:spPr>
-          <a:xfrm>
-            <a:off x="457200" y="1783080"/>
-            <a:ext cx="4160520" cy="2834640"/>
-          </a:xfrm>
-          <a:prstGeom prst="rect">
-            <a:avLst/>
-          </a:prstGeom>
-          <a:noFill/>
-          <a:ln/>
-        </p:spPr>
-        <p:txBody>
-          <a:bodyPr wrap="square" lIns="0" tIns="0" rIns="0" bIns="0" rtlCol="0" anchor="t">
-            <a:normAutofit/>
-          </a:bodyPr>
-          <a:lstStyle/>
-          <a:p>
-            <a:pPr indent="0" marL="0">
-              <a:spcAft>
-                <a:spcPts val="600"/>
-              </a:spcAft>
-              <a:buNone/>
-            </a:pPr>
-            <a:r>
-              <a:rPr lang="en-US" sz="1500" dirty="0">
-                <a:solidFill>
-                  <a:schemeClr val="tx1"/>
-                </a:solidFill>
-              </a:rPr>
-              <a:t>Vor dem endgültigen Massendurchbruch müssen die Produktionskosten weiter fallen und die Akkulaufzeit steigen. Experten sind zuversichtlich, dass diese Herausforderungen schon bald gelöst werden.</a:t>
-            </a:r>
-            <a:endParaRPr lang="en-US" sz="1500" dirty="0"/>
           </a:p>
         </p:txBody>
       </p:sp>
@@ -10946,8 +10831,8 @@
         </p:nvSpPr>
         <p:spPr>
           <a:xfrm>
-            <a:off x="5257800" y="822960"/>
-            <a:ext cx="3429000" cy="2651760"/>
+            <a:off x="5486400" y="822960"/>
+            <a:ext cx="3200400" cy="2651760"/>
           </a:xfrm>
           <a:prstGeom prst="roundRect">
             <a:avLst>
@@ -10973,8 +10858,8 @@
         </p:nvSpPr>
         <p:spPr>
           <a:xfrm>
-            <a:off x="5257800" y="960120"/>
-            <a:ext cx="3429000" cy="822960"/>
+            <a:off x="5486400" y="960120"/>
+            <a:ext cx="3200400" cy="822960"/>
           </a:xfrm>
           <a:prstGeom prst="rect">
             <a:avLst/>
@@ -11012,8 +10897,8 @@
         </p:nvSpPr>
         <p:spPr>
           <a:xfrm>
-            <a:off x="5486400" y="1874520"/>
-            <a:ext cx="2971800" cy="1463040"/>
+            <a:off x="5715000" y="1874520"/>
+            <a:ext cx="2743200" cy="1463040"/>
           </a:xfrm>
           <a:prstGeom prst="rect">
             <a:avLst/>
@@ -11048,8 +10933,8 @@
         </p:nvSpPr>
         <p:spPr>
           <a:xfrm>
-            <a:off x="5257800" y="3566160"/>
-            <a:ext cx="3429000" cy="228600"/>
+            <a:off x="5486400" y="3566160"/>
+            <a:ext cx="3200400" cy="228600"/>
           </a:xfrm>
           <a:prstGeom prst="rect">
             <a:avLst/>
@@ -11145,8 +11030,8 @@
         </p:nvSpPr>
         <p:spPr>
           <a:xfrm>
-            <a:off x="457200" y="640080"/>
-            <a:ext cx="4160520" cy="1051560"/>
+            <a:off x="457200" y="594360"/>
+            <a:ext cx="4572000" cy="1143000"/>
           </a:xfrm>
           <a:prstGeom prst="rect">
             <a:avLst/>
@@ -11164,7 +11049,7 @@
               <a:buNone/>
             </a:pPr>
             <a:r>
-              <a:rPr lang="en-US" sz="2400" b="1" dirty="0">
+              <a:rPr lang="en-US" sz="2600" b="1" dirty="0">
                 <a:solidFill>
                   <a:schemeClr val="tx2"/>
                 </a:solidFill>
@@ -11174,48 +11059,43 @@
               </a:rPr>
               <a:t>Die Zukunft: Mensch und Roboter als Team</a:t>
             </a:r>
+            <a:endParaRPr lang="en-US" sz="2600" dirty="0"/>
+          </a:p>
+        </p:txBody>
+      </p:sp>
+      <p:sp>
+        <p:nvSpPr>
+          <p:cNvPr id="4" name="Text"/>
+          <p:cNvSpPr txBox="1"/>
+          <p:nvPr/>
+        </p:nvSpPr>
+        <p:spPr>
+          <a:xfrm>
+            <a:off x="457200" y="1828800"/>
+            <a:ext cx="4572000" cy="2834640"/>
+          </a:xfrm>
+          <a:prstGeom prst="rect">
+            <a:avLst/>
+          </a:prstGeom>
+          <a:noFill/>
+          <a:ln/>
+        </p:spPr>
+        <p:txBody>
+          <a:bodyPr wrap="square" lIns="0" tIns="0" rIns="0" bIns="0" rtlCol="0" anchor="t"/>
+          <a:lstStyle/>
+          <a:p>
+            <a:pPr indent="0" marL="0">
+              <a:buNone/>
+            </a:pPr>
+            <a:r>
+              <a:rPr lang="en-US" sz="2400" dirty="0">
+                <a:solidFill>
+                  <a:schemeClr val="tx1"/>
+                </a:solidFill>
+              </a:rPr>
+              <a:t>Humanoide Roboter entwickeln sich rasant von Laborversuchen zu verlässlichen Partnern für Arbeit und Alltag. Sie werden uns schwere Lasten abnehmen und unser Zusammenleben nachhaltig verändern.</a:t>
+            </a:r>
             <a:endParaRPr lang="en-US" sz="2400" dirty="0"/>
-          </a:p>
-        </p:txBody>
-      </p:sp>
-      <p:sp>
-        <p:nvSpPr>
-          <p:cNvPr id="4" name="Text"/>
-          <p:cNvSpPr txBox="1"/>
-          <p:nvPr/>
-        </p:nvSpPr>
-        <p:spPr>
-          <a:xfrm>
-            <a:off x="457200" y="1783080"/>
-            <a:ext cx="4160520" cy="2834640"/>
-          </a:xfrm>
-          <a:prstGeom prst="rect">
-            <a:avLst/>
-          </a:prstGeom>
-          <a:noFill/>
-          <a:ln/>
-        </p:spPr>
-        <p:txBody>
-          <a:bodyPr wrap="square" lIns="0" tIns="0" rIns="0" bIns="0" rtlCol="0" anchor="t">
-            <a:normAutofit/>
-          </a:bodyPr>
-          <a:lstStyle/>
-          <a:p>
-            <a:pPr indent="0" marL="0">
-              <a:spcAft>
-                <a:spcPts val="600"/>
-              </a:spcAft>
-              <a:buNone/>
-            </a:pPr>
-            <a:r>
-              <a:rPr lang="en-US" sz="1500" dirty="0">
-                <a:solidFill>
-                  <a:schemeClr val="tx1"/>
-                </a:solidFill>
-              </a:rPr>
-              <a:t>Humanoide Roboter entwickeln sich rasant von Laborversuchen zu verlässlichen Partnern für Arbeit und Alltag. Sie werden uns schwere Lasten abnehmen und unser Zusammenleben nachhaltig verändern.</a:t>
-            </a:r>
-            <a:endParaRPr lang="en-US" sz="1500" dirty="0"/>
           </a:p>
         </p:txBody>
       </p:sp>
@@ -11263,8 +11143,8 @@
         </p:nvSpPr>
         <p:spPr>
           <a:xfrm>
-            <a:off x="5257800" y="822960"/>
-            <a:ext cx="3429000" cy="2651760"/>
+            <a:off x="5486400" y="822960"/>
+            <a:ext cx="3200400" cy="2651760"/>
           </a:xfrm>
           <a:prstGeom prst="roundRect">
             <a:avLst>
@@ -11290,8 +11170,8 @@
         </p:nvSpPr>
         <p:spPr>
           <a:xfrm>
-            <a:off x="5257800" y="960120"/>
-            <a:ext cx="3429000" cy="822960"/>
+            <a:off x="5486400" y="960120"/>
+            <a:ext cx="3200400" cy="822960"/>
           </a:xfrm>
           <a:prstGeom prst="rect">
             <a:avLst/>
@@ -11329,8 +11209,8 @@
         </p:nvSpPr>
         <p:spPr>
           <a:xfrm>
-            <a:off x="5486400" y="1874520"/>
-            <a:ext cx="2971800" cy="1463040"/>
+            <a:off x="5715000" y="1874520"/>
+            <a:ext cx="2743200" cy="1463040"/>
           </a:xfrm>
           <a:prstGeom prst="rect">
             <a:avLst/>
@@ -11365,8 +11245,8 @@
         </p:nvSpPr>
         <p:spPr>
           <a:xfrm>
-            <a:off x="5257800" y="3566160"/>
-            <a:ext cx="3429000" cy="228600"/>
+            <a:off x="5486400" y="3566160"/>
+            <a:ext cx="3200400" cy="228600"/>
           </a:xfrm>
           <a:prstGeom prst="rect">
             <a:avLst/>
@@ -11462,8 +11342,8 @@
         </p:nvSpPr>
         <p:spPr>
           <a:xfrm>
-            <a:off x="457200" y="640080"/>
-            <a:ext cx="4160520" cy="1051560"/>
+            <a:off x="457200" y="594360"/>
+            <a:ext cx="4572000" cy="1143000"/>
           </a:xfrm>
           <a:prstGeom prst="rect">
             <a:avLst/>
@@ -11481,7 +11361,7 @@
               <a:buNone/>
             </a:pPr>
             <a:r>
-              <a:rPr lang="en-US" sz="2400" b="1" dirty="0">
+              <a:rPr lang="en-US" sz="2600" b="1" dirty="0">
                 <a:solidFill>
                   <a:schemeClr val="tx2"/>
                 </a:solidFill>
@@ -11491,7 +11371,7 @@
               </a:rPr>
               <a:t>Pioniere: WABOT-1 und Honda ASIMO</a:t>
             </a:r>
-            <a:endParaRPr lang="en-US" sz="2400" dirty="0"/>
+            <a:endParaRPr lang="en-US" sz="2600" dirty="0"/>
           </a:p>
         </p:txBody>
       </p:sp>
@@ -11503,36 +11383,31 @@
         </p:nvSpPr>
         <p:spPr>
           <a:xfrm>
-            <a:off x="457200" y="1783080"/>
-            <a:ext cx="4160520" cy="2834640"/>
-          </a:xfrm>
-          <a:prstGeom prst="rect">
-            <a:avLst/>
-          </a:prstGeom>
-          <a:noFill/>
-          <a:ln/>
-        </p:spPr>
-        <p:txBody>
-          <a:bodyPr wrap="square" lIns="0" tIns="0" rIns="0" bIns="0" rtlCol="0" anchor="t">
-            <a:normAutofit/>
-          </a:bodyPr>
-          <a:lstStyle/>
-          <a:p>
-            <a:pPr indent="0" marL="0">
-              <a:spcAft>
-                <a:spcPts val="600"/>
-              </a:spcAft>
-              <a:buNone/>
-            </a:pPr>
-            <a:r>
-              <a:rPr lang="en-US" sz="1500" dirty="0">
+            <a:off x="457200" y="1828800"/>
+            <a:ext cx="4572000" cy="2834640"/>
+          </a:xfrm>
+          <a:prstGeom prst="rect">
+            <a:avLst/>
+          </a:prstGeom>
+          <a:noFill/>
+          <a:ln/>
+        </p:spPr>
+        <p:txBody>
+          <a:bodyPr wrap="square" lIns="0" tIns="0" rIns="0" bIns="0" rtlCol="0" anchor="t"/>
+          <a:lstStyle/>
+          <a:p>
+            <a:pPr indent="0" marL="0">
+              <a:buNone/>
+            </a:pPr>
+            <a:r>
+              <a:rPr lang="en-US" sz="2200" dirty="0">
                 <a:solidFill>
                   <a:schemeClr val="tx1"/>
                 </a:solidFill>
               </a:rPr>
               <a:t>Nach dem ersten zweibeinigen Roboter WABOT-1 aus Japan demonstrierte Honda mit ASIMO Jahre später erstmals flüssiges Gehen. Diese frühen Modelle begeisterten Millionen Menschen weltweit für die moderne Robotik.</a:t>
             </a:r>
-            <a:endParaRPr lang="en-US" sz="1500" dirty="0"/>
+            <a:endParaRPr lang="en-US" sz="2200" dirty="0"/>
           </a:p>
         </p:txBody>
       </p:sp>
@@ -11588,8 +11463,8 @@
         </p:blipFill>
         <p:spPr>
           <a:xfrm>
-            <a:off x="5257800" y="457200"/>
-            <a:ext cx="3429000" cy="3611880"/>
+            <a:off x="5486400" y="457200"/>
+            <a:ext cx="3200400" cy="3374136"/>
           </a:xfrm>
           <a:prstGeom prst="rect">
             <a:avLst/>
@@ -11604,8 +11479,8 @@
         </p:nvSpPr>
         <p:spPr>
           <a:xfrm>
-            <a:off x="5257800" y="4114800"/>
-            <a:ext cx="3429000" cy="201168"/>
+            <a:off x="5486400" y="3886200"/>
+            <a:ext cx="3200400" cy="201168"/>
           </a:xfrm>
           <a:prstGeom prst="rect">
             <a:avLst/>
@@ -11701,8 +11576,8 @@
         </p:nvSpPr>
         <p:spPr>
           <a:xfrm>
-            <a:off x="457200" y="640080"/>
-            <a:ext cx="4160520" cy="1051560"/>
+            <a:off x="457200" y="594360"/>
+            <a:ext cx="4572000" cy="1143000"/>
           </a:xfrm>
           <a:prstGeom prst="rect">
             <a:avLst/>
@@ -11720,7 +11595,7 @@
               <a:buNone/>
             </a:pPr>
             <a:r>
-              <a:rPr lang="en-US" sz="2400" b="1" dirty="0">
+              <a:rPr lang="en-US" sz="2600" b="1" dirty="0">
                 <a:solidFill>
                   <a:schemeClr val="tx2"/>
                 </a:solidFill>
@@ -11730,48 +11605,43 @@
               </a:rPr>
               <a:t>Boston Dynamics Atlas: Hydraulische Kraft (2013)</a:t>
             </a:r>
+            <a:endParaRPr lang="en-US" sz="2600" dirty="0"/>
+          </a:p>
+        </p:txBody>
+      </p:sp>
+      <p:sp>
+        <p:nvSpPr>
+          <p:cNvPr id="4" name="Text"/>
+          <p:cNvSpPr txBox="1"/>
+          <p:nvPr/>
+        </p:nvSpPr>
+        <p:spPr>
+          <a:xfrm>
+            <a:off x="457200" y="1828800"/>
+            <a:ext cx="4572000" cy="2834640"/>
+          </a:xfrm>
+          <a:prstGeom prst="rect">
+            <a:avLst/>
+          </a:prstGeom>
+          <a:noFill/>
+          <a:ln/>
+        </p:spPr>
+        <p:txBody>
+          <a:bodyPr wrap="square" lIns="0" tIns="0" rIns="0" bIns="0" rtlCol="0" anchor="t"/>
+          <a:lstStyle/>
+          <a:p>
+            <a:pPr indent="0" marL="0">
+              <a:buNone/>
+            </a:pPr>
+            <a:r>
+              <a:rPr lang="en-US" sz="2400" dirty="0">
+                <a:solidFill>
+                  <a:schemeClr val="tx1"/>
+                </a:solidFill>
+              </a:rPr>
+              <a:t>Die Ingenieure von Boston Dynamics bauten einen extrem robusten Roboter für raues Gelände. Seine kraftvollen Hydraulik-Muskeln ermöglichten erstaunlich dynamische Sprünge.</a:t>
+            </a:r>
             <a:endParaRPr lang="en-US" sz="2400" dirty="0"/>
-          </a:p>
-        </p:txBody>
-      </p:sp>
-      <p:sp>
-        <p:nvSpPr>
-          <p:cNvPr id="4" name="Text"/>
-          <p:cNvSpPr txBox="1"/>
-          <p:nvPr/>
-        </p:nvSpPr>
-        <p:spPr>
-          <a:xfrm>
-            <a:off x="457200" y="1783080"/>
-            <a:ext cx="4160520" cy="2834640"/>
-          </a:xfrm>
-          <a:prstGeom prst="rect">
-            <a:avLst/>
-          </a:prstGeom>
-          <a:noFill/>
-          <a:ln/>
-        </p:spPr>
-        <p:txBody>
-          <a:bodyPr wrap="square" lIns="0" tIns="0" rIns="0" bIns="0" rtlCol="0" anchor="t">
-            <a:normAutofit/>
-          </a:bodyPr>
-          <a:lstStyle/>
-          <a:p>
-            <a:pPr indent="0" marL="0">
-              <a:spcAft>
-                <a:spcPts val="600"/>
-              </a:spcAft>
-              <a:buNone/>
-            </a:pPr>
-            <a:r>
-              <a:rPr lang="en-US" sz="1500" dirty="0">
-                <a:solidFill>
-                  <a:schemeClr val="tx1"/>
-                </a:solidFill>
-              </a:rPr>
-              <a:t>Die Ingenieure von Boston Dynamics bauten einen extrem robusten Roboter für raues Gelände. Seine kraftvollen Hydraulik-Muskeln ermöglichten erstaunlich dynamische Sprünge.</a:t>
-            </a:r>
-            <a:endParaRPr lang="en-US" sz="1500" dirty="0"/>
           </a:p>
         </p:txBody>
       </p:sp>
@@ -11827,8 +11697,8 @@
         </p:blipFill>
         <p:spPr>
           <a:xfrm>
-            <a:off x="5257800" y="457200"/>
-            <a:ext cx="3429000" cy="3611880"/>
+            <a:off x="5486400" y="457200"/>
+            <a:ext cx="3200400" cy="3374136"/>
           </a:xfrm>
           <a:prstGeom prst="rect">
             <a:avLst/>
@@ -11843,8 +11713,8 @@
         </p:nvSpPr>
         <p:spPr>
           <a:xfrm>
-            <a:off x="5257800" y="4114800"/>
-            <a:ext cx="3429000" cy="201168"/>
+            <a:off x="5486400" y="3886200"/>
+            <a:ext cx="3200400" cy="201168"/>
           </a:xfrm>
           <a:prstGeom prst="rect">
             <a:avLst/>
@@ -11879,8 +11749,8 @@
         </p:nvSpPr>
         <p:spPr>
           <a:xfrm>
-            <a:off x="5257800" y="4389120"/>
-            <a:ext cx="3429000" cy="502920"/>
+            <a:off x="5486400" y="4160520"/>
+            <a:ext cx="3200400" cy="502920"/>
           </a:xfrm>
           <a:prstGeom prst="rect">
             <a:avLst/>
@@ -11997,8 +11867,8 @@
         </p:nvSpPr>
         <p:spPr>
           <a:xfrm>
-            <a:off x="457200" y="640080"/>
-            <a:ext cx="4160520" cy="1051560"/>
+            <a:off x="457200" y="594360"/>
+            <a:ext cx="4572000" cy="1143000"/>
           </a:xfrm>
           <a:prstGeom prst="rect">
             <a:avLst/>
@@ -12016,7 +11886,7 @@
               <a:buNone/>
             </a:pPr>
             <a:r>
-              <a:rPr lang="en-US" sz="2400" b="1" dirty="0">
+              <a:rPr lang="en-US" sz="2600" b="1" dirty="0">
                 <a:solidFill>
                   <a:schemeClr val="tx2"/>
                 </a:solidFill>
@@ -12026,48 +11896,43 @@
               </a:rPr>
               <a:t>Der neue vollelektrische Atlas (2024--2026)</a:t>
             </a:r>
+            <a:endParaRPr lang="en-US" sz="2600" dirty="0"/>
+          </a:p>
+        </p:txBody>
+      </p:sp>
+      <p:sp>
+        <p:nvSpPr>
+          <p:cNvPr id="4" name="Text"/>
+          <p:cNvSpPr txBox="1"/>
+          <p:nvPr/>
+        </p:nvSpPr>
+        <p:spPr>
+          <a:xfrm>
+            <a:off x="457200" y="1828800"/>
+            <a:ext cx="4572000" cy="2834640"/>
+          </a:xfrm>
+          <a:prstGeom prst="rect">
+            <a:avLst/>
+          </a:prstGeom>
+          <a:noFill/>
+          <a:ln/>
+        </p:spPr>
+        <p:txBody>
+          <a:bodyPr wrap="square" lIns="0" tIns="0" rIns="0" bIns="0" rtlCol="0" anchor="t"/>
+          <a:lstStyle/>
+          <a:p>
+            <a:pPr indent="0" marL="0">
+              <a:buNone/>
+            </a:pPr>
+            <a:r>
+              <a:rPr lang="en-US" sz="2400" dirty="0">
+                <a:solidFill>
+                  <a:schemeClr val="tx1"/>
+                </a:solidFill>
+              </a:rPr>
+              <a:t>Der neue Atlas besitzt moderne Elektromotoren und kann seine Gelenke um 360 Grad rotieren. Dadurch bewegt er sich viel leiser, geschmeidiger und energieeffizienter als früher.</a:t>
+            </a:r>
             <a:endParaRPr lang="en-US" sz="2400" dirty="0"/>
-          </a:p>
-        </p:txBody>
-      </p:sp>
-      <p:sp>
-        <p:nvSpPr>
-          <p:cNvPr id="4" name="Text"/>
-          <p:cNvSpPr txBox="1"/>
-          <p:nvPr/>
-        </p:nvSpPr>
-        <p:spPr>
-          <a:xfrm>
-            <a:off x="457200" y="1783080"/>
-            <a:ext cx="4160520" cy="2834640"/>
-          </a:xfrm>
-          <a:prstGeom prst="rect">
-            <a:avLst/>
-          </a:prstGeom>
-          <a:noFill/>
-          <a:ln/>
-        </p:spPr>
-        <p:txBody>
-          <a:bodyPr wrap="square" lIns="0" tIns="0" rIns="0" bIns="0" rtlCol="0" anchor="t">
-            <a:normAutofit/>
-          </a:bodyPr>
-          <a:lstStyle/>
-          <a:p>
-            <a:pPr indent="0" marL="0">
-              <a:spcAft>
-                <a:spcPts val="600"/>
-              </a:spcAft>
-              <a:buNone/>
-            </a:pPr>
-            <a:r>
-              <a:rPr lang="en-US" sz="1500" dirty="0">
-                <a:solidFill>
-                  <a:schemeClr val="tx1"/>
-                </a:solidFill>
-              </a:rPr>
-              <a:t>Der neue Atlas besitzt moderne Elektromotoren und kann seine Gelenke um 360 Grad rotieren. Dadurch bewegt er sich viel leiser, geschmeidiger und energieeffizienter als früher.</a:t>
-            </a:r>
-            <a:endParaRPr lang="en-US" sz="1500" dirty="0"/>
           </a:p>
         </p:txBody>
       </p:sp>
@@ -12125,8 +11990,8 @@
         </p:blipFill>
         <p:spPr>
           <a:xfrm>
-            <a:off x="5257800" y="822960"/>
-            <a:ext cx="3429000" cy="1928813"/>
+            <a:off x="5486400" y="822960"/>
+            <a:ext cx="3200400" cy="1800225"/>
           </a:xfrm>
           <a:prstGeom prst="rect">
             <a:avLst/>
@@ -12143,7 +12008,7 @@
         </p:nvSpPr>
         <p:spPr>
           <a:xfrm>
-            <a:off x="6652260" y="1467326"/>
+            <a:off x="6766560" y="1403032"/>
             <a:ext cx="640080" cy="640080"/>
           </a:xfrm>
           <a:prstGeom prst="ellipse">
@@ -12172,7 +12037,7 @@
         </p:nvSpPr>
         <p:spPr>
           <a:xfrm rot="5400000">
-            <a:off x="6880860" y="1641062"/>
+            <a:off x="6995160" y="1576769"/>
             <a:ext cx="256032" cy="292608"/>
           </a:xfrm>
           <a:prstGeom prst="triangle">
@@ -12197,8 +12062,8 @@
         </p:nvSpPr>
         <p:spPr>
           <a:xfrm>
-            <a:off x="5257800" y="2843213"/>
-            <a:ext cx="3429000" cy="548640"/>
+            <a:off x="5486400" y="2714625"/>
+            <a:ext cx="3200400" cy="548640"/>
           </a:xfrm>
           <a:prstGeom prst="rect">
             <a:avLst/>
@@ -12233,8 +12098,8 @@
         </p:nvSpPr>
         <p:spPr>
           <a:xfrm>
-            <a:off x="5257800" y="3566160"/>
-            <a:ext cx="3429000" cy="502920"/>
+            <a:off x="5486400" y="3566160"/>
+            <a:ext cx="3200400" cy="502920"/>
           </a:xfrm>
           <a:prstGeom prst="rect">
             <a:avLst/>
@@ -12351,8 +12216,8 @@
         </p:nvSpPr>
         <p:spPr>
           <a:xfrm>
-            <a:off x="457200" y="640080"/>
-            <a:ext cx="4160520" cy="1051560"/>
+            <a:off x="457200" y="594360"/>
+            <a:ext cx="4572000" cy="1143000"/>
           </a:xfrm>
           <a:prstGeom prst="rect">
             <a:avLst/>
@@ -12370,7 +12235,7 @@
               <a:buNone/>
             </a:pPr>
             <a:r>
-              <a:rPr lang="en-US" sz="2400" b="1" dirty="0">
+              <a:rPr lang="en-US" sz="2600" b="1" dirty="0">
                 <a:solidFill>
                   <a:schemeClr val="tx2"/>
                 </a:solidFill>
@@ -12380,7 +12245,7 @@
               </a:rPr>
               <a:t>Roboter-Wettkämpfe: Olympia und RoboCup</a:t>
             </a:r>
-            <a:endParaRPr lang="en-US" sz="2400" dirty="0"/>
+            <a:endParaRPr lang="en-US" sz="2600" dirty="0"/>
           </a:p>
         </p:txBody>
       </p:sp>
@@ -12392,36 +12257,31 @@
         </p:nvSpPr>
         <p:spPr>
           <a:xfrm>
-            <a:off x="457200" y="1783080"/>
-            <a:ext cx="4160520" cy="2834640"/>
-          </a:xfrm>
-          <a:prstGeom prst="rect">
-            <a:avLst/>
-          </a:prstGeom>
-          <a:noFill/>
-          <a:ln/>
-        </p:spPr>
-        <p:txBody>
-          <a:bodyPr wrap="square" lIns="0" tIns="0" rIns="0" bIns="0" rtlCol="0" anchor="t">
-            <a:normAutofit/>
-          </a:bodyPr>
-          <a:lstStyle/>
-          <a:p>
-            <a:pPr indent="0" marL="0">
-              <a:spcAft>
-                <a:spcPts val="600"/>
-              </a:spcAft>
-              <a:buNone/>
-            </a:pPr>
-            <a:r>
-              <a:rPr lang="en-US" sz="1500" dirty="0">
+            <a:off x="457200" y="1828800"/>
+            <a:ext cx="4572000" cy="2834640"/>
+          </a:xfrm>
+          <a:prstGeom prst="rect">
+            <a:avLst/>
+          </a:prstGeom>
+          <a:noFill/>
+          <a:ln/>
+        </p:spPr>
+        <p:txBody>
+          <a:bodyPr wrap="square" lIns="0" tIns="0" rIns="0" bIns="0" rtlCol="0" anchor="t"/>
+          <a:lstStyle/>
+          <a:p>
+            <a:pPr indent="0" marL="0">
+              <a:buNone/>
+            </a:pPr>
+            <a:r>
+              <a:rPr lang="en-US" sz="2200" dirty="0">
                 <a:solidFill>
                   <a:schemeClr val="tx1"/>
                 </a:solidFill>
               </a:rPr>
               <a:t>In Peking messen sich Humanoide bereits in sportlichen Disziplinen wie dem Sprint, während beim RoboCup autonome Teams Fußball spielen. Das ehrgeizige Ziel ist ein Sieg gegen menschliche Fußball-Weltmeister bis zum Jahr 2050.</a:t>
             </a:r>
-            <a:endParaRPr lang="en-US" sz="1500" dirty="0"/>
+            <a:endParaRPr lang="en-US" sz="2200" dirty="0"/>
           </a:p>
         </p:txBody>
       </p:sp>
@@ -12469,8 +12329,8 @@
         </p:nvSpPr>
         <p:spPr>
           <a:xfrm>
-            <a:off x="5257800" y="822960"/>
-            <a:ext cx="3429000" cy="2651760"/>
+            <a:off x="5486400" y="822960"/>
+            <a:ext cx="3200400" cy="2651760"/>
           </a:xfrm>
           <a:prstGeom prst="roundRect">
             <a:avLst>
@@ -12496,8 +12356,8 @@
         </p:nvSpPr>
         <p:spPr>
           <a:xfrm>
-            <a:off x="5257800" y="960120"/>
-            <a:ext cx="3429000" cy="822960"/>
+            <a:off x="5486400" y="960120"/>
+            <a:ext cx="3200400" cy="822960"/>
           </a:xfrm>
           <a:prstGeom prst="rect">
             <a:avLst/>
@@ -12535,8 +12395,8 @@
         </p:nvSpPr>
         <p:spPr>
           <a:xfrm>
-            <a:off x="5486400" y="1874520"/>
-            <a:ext cx="2971800" cy="1463040"/>
+            <a:off x="5715000" y="1874520"/>
+            <a:ext cx="2743200" cy="1463040"/>
           </a:xfrm>
           <a:prstGeom prst="rect">
             <a:avLst/>
@@ -12571,8 +12431,8 @@
         </p:nvSpPr>
         <p:spPr>
           <a:xfrm>
-            <a:off x="5257800" y="3566160"/>
-            <a:ext cx="3429000" cy="228600"/>
+            <a:off x="5486400" y="3566160"/>
+            <a:ext cx="3200400" cy="228600"/>
           </a:xfrm>
           <a:prstGeom prst="rect">
             <a:avLst/>
@@ -12668,8 +12528,8 @@
         </p:nvSpPr>
         <p:spPr>
           <a:xfrm>
-            <a:off x="457200" y="640080"/>
-            <a:ext cx="4160520" cy="1051560"/>
+            <a:off x="457200" y="594360"/>
+            <a:ext cx="4572000" cy="1143000"/>
           </a:xfrm>
           <a:prstGeom prst="rect">
             <a:avLst/>
@@ -12687,7 +12547,7 @@
               <a:buNone/>
             </a:pPr>
             <a:r>
-              <a:rPr lang="en-US" sz="2400" b="1" dirty="0">
+              <a:rPr lang="en-US" sz="2600" b="1" dirty="0">
                 <a:solidFill>
                   <a:schemeClr val="tx2"/>
                 </a:solidFill>
@@ -12697,48 +12557,43 @@
               </a:rPr>
               <a:t>URKL: Professionelles Roboter-Boxen im Ring</a:t>
             </a:r>
+            <a:endParaRPr lang="en-US" sz="2600" dirty="0"/>
+          </a:p>
+        </p:txBody>
+      </p:sp>
+      <p:sp>
+        <p:nvSpPr>
+          <p:cNvPr id="4" name="Text"/>
+          <p:cNvSpPr txBox="1"/>
+          <p:nvPr/>
+        </p:nvSpPr>
+        <p:spPr>
+          <a:xfrm>
+            <a:off x="457200" y="1828800"/>
+            <a:ext cx="4572000" cy="2834640"/>
+          </a:xfrm>
+          <a:prstGeom prst="rect">
+            <a:avLst/>
+          </a:prstGeom>
+          <a:noFill/>
+          <a:ln/>
+        </p:spPr>
+        <p:txBody>
+          <a:bodyPr wrap="square" lIns="0" tIns="0" rIns="0" bIns="0" rtlCol="0" anchor="t"/>
+          <a:lstStyle/>
+          <a:p>
+            <a:pPr indent="0" marL="0">
+              <a:buNone/>
+            </a:pPr>
+            <a:r>
+              <a:rPr lang="en-US" sz="2400" dirty="0">
+                <a:solidFill>
+                  <a:schemeClr val="tx1"/>
+                </a:solidFill>
+              </a:rPr>
+              <a:t>In neuen Kampfsportligen wie der URKL treten humanoide Roboter in einem echten Boxring gegeneinander an. Fällt ein Roboter zu Boden, muss er innerhalb weniger Sekunden selbstständig aufstehen.</a:t>
+            </a:r>
             <a:endParaRPr lang="en-US" sz="2400" dirty="0"/>
-          </a:p>
-        </p:txBody>
-      </p:sp>
-      <p:sp>
-        <p:nvSpPr>
-          <p:cNvPr id="4" name="Text"/>
-          <p:cNvSpPr txBox="1"/>
-          <p:nvPr/>
-        </p:nvSpPr>
-        <p:spPr>
-          <a:xfrm>
-            <a:off x="457200" y="1783080"/>
-            <a:ext cx="4160520" cy="2834640"/>
-          </a:xfrm>
-          <a:prstGeom prst="rect">
-            <a:avLst/>
-          </a:prstGeom>
-          <a:noFill/>
-          <a:ln/>
-        </p:spPr>
-        <p:txBody>
-          <a:bodyPr wrap="square" lIns="0" tIns="0" rIns="0" bIns="0" rtlCol="0" anchor="t">
-            <a:normAutofit/>
-          </a:bodyPr>
-          <a:lstStyle/>
-          <a:p>
-            <a:pPr indent="0" marL="0">
-              <a:spcAft>
-                <a:spcPts val="600"/>
-              </a:spcAft>
-              <a:buNone/>
-            </a:pPr>
-            <a:r>
-              <a:rPr lang="en-US" sz="1500" dirty="0">
-                <a:solidFill>
-                  <a:schemeClr val="tx1"/>
-                </a:solidFill>
-              </a:rPr>
-              <a:t>In neuen Kampfsportligen wie der URKL treten humanoide Roboter in einem echten Boxring gegeneinander an. Fällt ein Roboter zu Boden, muss er innerhalb weniger Sekunden selbstständig aufstehen.</a:t>
-            </a:r>
-            <a:endParaRPr lang="en-US" sz="1500" dirty="0"/>
           </a:p>
         </p:txBody>
       </p:sp>
@@ -12796,8 +12651,8 @@
         </p:blipFill>
         <p:spPr>
           <a:xfrm>
-            <a:off x="5257800" y="822960"/>
-            <a:ext cx="3429000" cy="1928813"/>
+            <a:off x="5486400" y="822960"/>
+            <a:ext cx="3200400" cy="1800225"/>
           </a:xfrm>
           <a:prstGeom prst="rect">
             <a:avLst/>
@@ -12814,7 +12669,7 @@
         </p:nvSpPr>
         <p:spPr>
           <a:xfrm>
-            <a:off x="6652260" y="1467326"/>
+            <a:off x="6766560" y="1403032"/>
             <a:ext cx="640080" cy="640080"/>
           </a:xfrm>
           <a:prstGeom prst="ellipse">
@@ -12843,7 +12698,7 @@
         </p:nvSpPr>
         <p:spPr>
           <a:xfrm rot="5400000">
-            <a:off x="6880860" y="1641062"/>
+            <a:off x="6995160" y="1576769"/>
             <a:ext cx="256032" cy="292608"/>
           </a:xfrm>
           <a:prstGeom prst="triangle">
@@ -12868,8 +12723,8 @@
         </p:nvSpPr>
         <p:spPr>
           <a:xfrm>
-            <a:off x="5257800" y="2843213"/>
-            <a:ext cx="3429000" cy="548640"/>
+            <a:off x="5486400" y="2714625"/>
+            <a:ext cx="3200400" cy="548640"/>
           </a:xfrm>
           <a:prstGeom prst="rect">
             <a:avLst/>
@@ -12904,8 +12759,8 @@
         </p:nvSpPr>
         <p:spPr>
           <a:xfrm>
-            <a:off x="5257800" y="3566160"/>
-            <a:ext cx="3429000" cy="502920"/>
+            <a:off x="5486400" y="3566160"/>
+            <a:ext cx="3200400" cy="502920"/>
           </a:xfrm>
           <a:prstGeom prst="rect">
             <a:avLst/>
@@ -13022,8 +12877,8 @@
         </p:nvSpPr>
         <p:spPr>
           <a:xfrm>
-            <a:off x="457200" y="640080"/>
-            <a:ext cx="4160520" cy="1051560"/>
+            <a:off x="457200" y="594360"/>
+            <a:ext cx="4572000" cy="1143000"/>
           </a:xfrm>
           <a:prstGeom prst="rect">
             <a:avLst/>
@@ -13041,7 +12896,7 @@
               <a:buNone/>
             </a:pPr>
             <a:r>
-              <a:rPr lang="en-US" sz="2400" b="1" dirty="0">
+              <a:rPr lang="en-US" sz="2600" b="1" dirty="0">
                 <a:solidFill>
                   <a:schemeClr val="tx2"/>
                 </a:solidFill>
@@ -13051,48 +12906,43 @@
               </a:rPr>
               <a:t>Mensch gegen Maschine: Duelle im Ring</a:t>
             </a:r>
+            <a:endParaRPr lang="en-US" sz="2600" dirty="0"/>
+          </a:p>
+        </p:txBody>
+      </p:sp>
+      <p:sp>
+        <p:nvSpPr>
+          <p:cNvPr id="4" name="Text"/>
+          <p:cNvSpPr txBox="1"/>
+          <p:nvPr/>
+        </p:nvSpPr>
+        <p:spPr>
+          <a:xfrm>
+            <a:off x="457200" y="1828800"/>
+            <a:ext cx="4572000" cy="2834640"/>
+          </a:xfrm>
+          <a:prstGeom prst="rect">
+            <a:avLst/>
+          </a:prstGeom>
+          <a:noFill/>
+          <a:ln/>
+        </p:spPr>
+        <p:txBody>
+          <a:bodyPr wrap="square" lIns="0" tIns="0" rIns="0" bIns="0" rtlCol="0" anchor="t"/>
+          <a:lstStyle/>
+          <a:p>
+            <a:pPr indent="0" marL="0">
+              <a:buNone/>
+            </a:pPr>
+            <a:r>
+              <a:rPr lang="en-US" sz="2400" dirty="0">
+                <a:solidFill>
+                  <a:schemeClr val="tx1"/>
+                </a:solidFill>
+              </a:rPr>
+              <a:t>Erste Schaukämpfe zwischen menschlichen Sportlern und humanoiden Robotern erregten weltweites Aufsehen. Schnelle Schutzsensoren und Softwarealgorithmen verhindern dabei gefährliche Verletzungen.</a:t>
+            </a:r>
             <a:endParaRPr lang="en-US" sz="2400" dirty="0"/>
-          </a:p>
-        </p:txBody>
-      </p:sp>
-      <p:sp>
-        <p:nvSpPr>
-          <p:cNvPr id="4" name="Text"/>
-          <p:cNvSpPr txBox="1"/>
-          <p:nvPr/>
-        </p:nvSpPr>
-        <p:spPr>
-          <a:xfrm>
-            <a:off x="457200" y="1783080"/>
-            <a:ext cx="4160520" cy="2834640"/>
-          </a:xfrm>
-          <a:prstGeom prst="rect">
-            <a:avLst/>
-          </a:prstGeom>
-          <a:noFill/>
-          <a:ln/>
-        </p:spPr>
-        <p:txBody>
-          <a:bodyPr wrap="square" lIns="0" tIns="0" rIns="0" bIns="0" rtlCol="0" anchor="t">
-            <a:normAutofit/>
-          </a:bodyPr>
-          <a:lstStyle/>
-          <a:p>
-            <a:pPr indent="0" marL="0">
-              <a:spcAft>
-                <a:spcPts val="600"/>
-              </a:spcAft>
-              <a:buNone/>
-            </a:pPr>
-            <a:r>
-              <a:rPr lang="en-US" sz="1500" dirty="0">
-                <a:solidFill>
-                  <a:schemeClr val="tx1"/>
-                </a:solidFill>
-              </a:rPr>
-              <a:t>Erste Schaukämpfe zwischen menschlichen Sportlern und humanoiden Robotern erregten weltweites Aufsehen. Schnelle Schutzsensoren und Softwarealgorithmen verhindern dabei gefährliche Verletzungen.</a:t>
-            </a:r>
-            <a:endParaRPr lang="en-US" sz="1500" dirty="0"/>
           </a:p>
         </p:txBody>
       </p:sp>
@@ -13150,8 +13000,8 @@
         </p:blipFill>
         <p:spPr>
           <a:xfrm>
-            <a:off x="5257800" y="822960"/>
-            <a:ext cx="3429000" cy="1928813"/>
+            <a:off x="5486400" y="822960"/>
+            <a:ext cx="3200400" cy="1800225"/>
           </a:xfrm>
           <a:prstGeom prst="rect">
             <a:avLst/>
@@ -13168,7 +13018,7 @@
         </p:nvSpPr>
         <p:spPr>
           <a:xfrm>
-            <a:off x="6652260" y="1467326"/>
+            <a:off x="6766560" y="1403032"/>
             <a:ext cx="640080" cy="640080"/>
           </a:xfrm>
           <a:prstGeom prst="ellipse">
@@ -13197,7 +13047,7 @@
         </p:nvSpPr>
         <p:spPr>
           <a:xfrm rot="5400000">
-            <a:off x="6880860" y="1641062"/>
+            <a:off x="6995160" y="1576769"/>
             <a:ext cx="256032" cy="292608"/>
           </a:xfrm>
           <a:prstGeom prst="triangle">
@@ -13222,8 +13072,8 @@
         </p:nvSpPr>
         <p:spPr>
           <a:xfrm>
-            <a:off x="5257800" y="2843213"/>
-            <a:ext cx="3429000" cy="548640"/>
+            <a:off x="5486400" y="2714625"/>
+            <a:ext cx="3200400" cy="548640"/>
           </a:xfrm>
           <a:prstGeom prst="rect">
             <a:avLst/>
@@ -13258,8 +13108,8 @@
         </p:nvSpPr>
         <p:spPr>
           <a:xfrm>
-            <a:off x="5257800" y="3566160"/>
-            <a:ext cx="3429000" cy="502920"/>
+            <a:off x="5486400" y="3566160"/>
+            <a:ext cx="3200400" cy="502920"/>
           </a:xfrm>
           <a:prstGeom prst="rect">
             <a:avLst/>

</xml_diff>